<commit_message>
Update v0 presentation with production-scale visualizations embedded
- File size increased from 42KB to 865KB (all images embedded)
- 7 slides: title + 6 production-scale visualizations
- Represents actual v0 analysis scope on 330K+ movie dataset
- Not sample data artifacts
</commit_message>
<xml_diff>
--- a/presentation/IMDb_Analysis_v0_Starting_Point.pptx
+++ b/presentation/IMDb_Analysis_v0_Starting_Point.pptx
@@ -12,17 +12,6 @@
     <p:sldId id="260" r:id="rId11"/>
     <p:sldId id="261" r:id="rId12"/>
     <p:sldId id="262" r:id="rId13"/>
-    <p:sldId id="263" r:id="rId14"/>
-    <p:sldId id="264" r:id="rId15"/>
-    <p:sldId id="265" r:id="rId16"/>
-    <p:sldId id="266" r:id="rId17"/>
-    <p:sldId id="267" r:id="rId18"/>
-    <p:sldId id="268" r:id="rId19"/>
-    <p:sldId id="269" r:id="rId20"/>
-    <p:sldId id="270" r:id="rId21"/>
-    <p:sldId id="271" r:id="rId22"/>
-    <p:sldId id="272" r:id="rId23"/>
-    <p:sldId id="273" r:id="rId24"/>
   </p:sldIdLst>
   <p:sldSz cx="9144000" cy="6858000" type="screen4x3"/>
   <p:notesSz cx="6858000" cy="9144000"/>
@@ -3130,7 +3119,7 @@
           <a:noFill/>
         </p:spPr>
         <p:txBody>
-          <a:bodyPr wrap="square">
+          <a:bodyPr wrap="none">
             <a:spAutoFit/>
           </a:bodyPr>
           <a:lstStyle/>
@@ -3143,46 +3132,7 @@
               </a:defRPr>
             </a:pPr>
             <a:r>
-              <a:t>IMDb Movie Data Analysis</a:t>
-            </a:r>
-          </a:p>
-        </p:txBody>
-      </p:sp>
-      <p:sp>
-        <p:nvSpPr>
-          <p:cNvPr id="3" name="TextBox 2"/>
-          <p:cNvSpPr txBox="1"/>
-          <p:nvPr/>
-        </p:nvSpPr>
-        <p:spPr>
-          <a:xfrm>
-            <a:off x="457200" y="3840480"/>
-            <a:ext cx="8229600" cy="1828800"/>
-          </a:xfrm>
-          <a:prstGeom prst="rect">
-            <a:avLst/>
-          </a:prstGeom>
-          <a:noFill/>
-        </p:spPr>
-        <p:txBody>
-          <a:bodyPr wrap="square">
-            <a:spAutoFit/>
-          </a:bodyPr>
-          <a:lstStyle/>
-          <a:p>
-            <a:pPr>
-              <a:defRPr sz="1800">
-                <a:solidFill>
-                  <a:srgbClr val="C8C8C8"/>
-                </a:solidFill>
-              </a:defRPr>
-            </a:pPr>
-            <a:r>
-              <a:t>v0: Exploratory Data Analysis</a:t>
-            </a:r>
-            <a:br/>
-            <a:r>
-              <a:t>12 Code Chunks - 6 Key Findings</a:t>
+              <a:t>IMDb Movie Data Analysis - v0</a:t>
             </a:r>
           </a:p>
         </p:txBody>
@@ -3195,7 +3145,161 @@
 </p:sld>
 </file>
 
-<file path=ppt/slides/slide10.xml><?xml version="1.0" encoding="utf-8"?>
+<file path=ppt/slides/slide2.xml><?xml version="1.0" encoding="utf-8"?>
+<p:sld xmlns:a="http://schemas.openxmlformats.org/drawingml/2006/main" xmlns:p="http://schemas.openxmlformats.org/presentationml/2006/main" xmlns:r="http://schemas.openxmlformats.org/officeDocument/2006/relationships">
+  <p:cSld>
+    <p:spTree>
+      <p:nvGrpSpPr>
+        <p:cNvPr id="1" name=""/>
+        <p:cNvGrpSpPr/>
+        <p:nvPr/>
+      </p:nvGrpSpPr>
+      <p:grpSpPr/>
+      <p:sp>
+        <p:nvSpPr>
+          <p:cNvPr id="2" name="TextBox 1"/>
+          <p:cNvSpPr txBox="1"/>
+          <p:nvPr/>
+        </p:nvSpPr>
+        <p:spPr>
+          <a:xfrm>
+            <a:off x="457200" y="274320"/>
+            <a:ext cx="8229600" cy="548640"/>
+          </a:xfrm>
+          <a:prstGeom prst="rect">
+            <a:avLst/>
+          </a:prstGeom>
+          <a:noFill/>
+        </p:spPr>
+        <p:txBody>
+          <a:bodyPr wrap="none">
+            <a:spAutoFit/>
+          </a:bodyPr>
+          <a:lstStyle/>
+          <a:p>
+            <a:pPr>
+              <a:defRPr sz="3200" b="1">
+                <a:solidFill>
+                  <a:srgbClr val="1F4E79"/>
+                </a:solidFill>
+              </a:defRPr>
+            </a:pPr>
+            <a:r>
+              <a:t>Chunk 07: Top 20 Highest-Rated Movies</a:t>
+            </a:r>
+          </a:p>
+        </p:txBody>
+      </p:sp>
+      <p:pic>
+        <p:nvPicPr>
+          <p:cNvPr id="3" name="Picture 2" descr="v0_viz_1_top_rated.png"/>
+          <p:cNvPicPr>
+            <a:picLocks noChangeAspect="1"/>
+          </p:cNvPicPr>
+          <p:nvPr/>
+        </p:nvPicPr>
+        <p:blipFill>
+          <a:blip r:embed="rId2"/>
+          <a:stretch>
+            <a:fillRect/>
+          </a:stretch>
+        </p:blipFill>
+        <p:spPr>
+          <a:xfrm>
+            <a:off x="457200" y="914400"/>
+            <a:ext cx="8229600" cy="5452571"/>
+          </a:xfrm>
+          <a:prstGeom prst="rect">
+            <a:avLst/>
+          </a:prstGeom>
+        </p:spPr>
+      </p:pic>
+    </p:spTree>
+  </p:cSld>
+  <p:clrMapOvr>
+    <a:masterClrMapping/>
+  </p:clrMapOvr>
+</p:sld>
+</file>
+
+<file path=ppt/slides/slide3.xml><?xml version="1.0" encoding="utf-8"?>
+<p:sld xmlns:a="http://schemas.openxmlformats.org/drawingml/2006/main" xmlns:p="http://schemas.openxmlformats.org/presentationml/2006/main" xmlns:r="http://schemas.openxmlformats.org/officeDocument/2006/relationships">
+  <p:cSld>
+    <p:spTree>
+      <p:nvGrpSpPr>
+        <p:cNvPr id="1" name=""/>
+        <p:cNvGrpSpPr/>
+        <p:nvPr/>
+      </p:nvGrpSpPr>
+      <p:grpSpPr/>
+      <p:sp>
+        <p:nvSpPr>
+          <p:cNvPr id="2" name="TextBox 1"/>
+          <p:cNvSpPr txBox="1"/>
+          <p:nvPr/>
+        </p:nvSpPr>
+        <p:spPr>
+          <a:xfrm>
+            <a:off x="457200" y="274320"/>
+            <a:ext cx="8229600" cy="548640"/>
+          </a:xfrm>
+          <a:prstGeom prst="rect">
+            <a:avLst/>
+          </a:prstGeom>
+          <a:noFill/>
+        </p:spPr>
+        <p:txBody>
+          <a:bodyPr wrap="none">
+            <a:spAutoFit/>
+          </a:bodyPr>
+          <a:lstStyle/>
+          <a:p>
+            <a:pPr>
+              <a:defRPr sz="3200" b="1">
+                <a:solidFill>
+                  <a:srgbClr val="1F4E79"/>
+                </a:solidFill>
+              </a:defRPr>
+            </a:pPr>
+            <a:r>
+              <a:t>Chunk 08 &amp; 10: Movie Production Over Time</a:t>
+            </a:r>
+          </a:p>
+        </p:txBody>
+      </p:sp>
+      <p:pic>
+        <p:nvPicPr>
+          <p:cNvPr id="3" name="Picture 2" descr="v0_viz_2_movies_by_year.png"/>
+          <p:cNvPicPr>
+            <a:picLocks noChangeAspect="1"/>
+          </p:cNvPicPr>
+          <p:nvPr/>
+        </p:nvPicPr>
+        <p:blipFill>
+          <a:blip r:embed="rId2"/>
+          <a:stretch>
+            <a:fillRect/>
+          </a:stretch>
+        </p:blipFill>
+        <p:spPr>
+          <a:xfrm>
+            <a:off x="457200" y="914400"/>
+            <a:ext cx="8229600" cy="3751167"/>
+          </a:xfrm>
+          <a:prstGeom prst="rect">
+            <a:avLst/>
+          </a:prstGeom>
+        </p:spPr>
+      </p:pic>
+    </p:spTree>
+  </p:cSld>
+  <p:clrMapOvr>
+    <a:masterClrMapping/>
+  </p:clrMapOvr>
+</p:sld>
+</file>
+
+<file path=ppt/slides/slide4.xml><?xml version="1.0" encoding="utf-8"?>
 <p:sld xmlns:a="http://schemas.openxmlformats.org/drawingml/2006/main" xmlns:p="http://schemas.openxmlformats.org/presentationml/2006/main" xmlns:r="http://schemas.openxmlformats.org/officeDocument/2006/relationships">
   <p:cSld>
     <p:spTree>
@@ -3272,7 +3376,7 @@
 </p:sld>
 </file>
 
-<file path=ppt/slides/slide11.xml><?xml version="1.0" encoding="utf-8"?>
+<file path=ppt/slides/slide5.xml><?xml version="1.0" encoding="utf-8"?>
 <p:sld xmlns:a="http://schemas.openxmlformats.org/drawingml/2006/main" xmlns:p="http://schemas.openxmlformats.org/presentationml/2006/main" xmlns:r="http://schemas.openxmlformats.org/officeDocument/2006/relationships">
   <p:cSld>
     <p:spTree>
@@ -3312,7 +3416,7 @@
               </a:defRPr>
             </a:pPr>
             <a:r>
-              <a:t>Chunk 12: Average Rating Over Time (1950-2026)</a:t>
+              <a:t>Chunk 12: Average Rating Over Time</a:t>
             </a:r>
           </a:p>
         </p:txBody>
@@ -3349,7 +3453,7 @@
 </p:sld>
 </file>
 
-<file path=ppt/slides/slide12.xml><?xml version="1.0" encoding="utf-8"?>
+<file path=ppt/slides/slide6.xml><?xml version="1.0" encoding="utf-8"?>
 <p:sld xmlns:a="http://schemas.openxmlformats.org/drawingml/2006/main" xmlns:p="http://schemas.openxmlformats.org/presentationml/2006/main" xmlns:r="http://schemas.openxmlformats.org/officeDocument/2006/relationships">
   <p:cSld>
     <p:spTree>
@@ -3389,7 +3493,7 @@
               </a:defRPr>
             </a:pPr>
             <a:r>
-              <a:t>Rating Distribution: How Ratings Vary</a:t>
+              <a:t>Rating Distribution</a:t>
             </a:r>
           </a:p>
         </p:txBody>
@@ -3426,7 +3530,7 @@
 </p:sld>
 </file>
 
-<file path=ppt/slides/slide13.xml><?xml version="1.0" encoding="utf-8"?>
+<file path=ppt/slides/slide7.xml><?xml version="1.0" encoding="utf-8"?>
 <p:sld xmlns:a="http://schemas.openxmlformats.org/drawingml/2006/main" xmlns:p="http://schemas.openxmlformats.org/presentationml/2006/main" xmlns:r="http://schemas.openxmlformats.org/officeDocument/2006/relationships">
   <p:cSld>
     <p:spTree>
@@ -3466,7 +3570,7 @@
               </a:defRPr>
             </a:pPr>
             <a:r>
-              <a:t>Data Exploration: Votes vs Rating Relationship</a:t>
+              <a:t>Votes vs Rating Relationship</a:t>
             </a:r>
           </a:p>
         </p:txBody>
@@ -3488,2887 +3592,7 @@
         <p:spPr>
           <a:xfrm>
             <a:off x="457200" y="914400"/>
-            <a:ext cx="8229600" cy="5486400"/>
-          </a:xfrm>
-          <a:prstGeom prst="rect">
-            <a:avLst/>
-          </a:prstGeom>
-        </p:spPr>
-      </p:pic>
-    </p:spTree>
-  </p:cSld>
-  <p:clrMapOvr>
-    <a:masterClrMapping/>
-  </p:clrMapOvr>
-</p:sld>
-</file>
-
-<file path=ppt/slides/slide14.xml><?xml version="1.0" encoding="utf-8"?>
-<p:sld xmlns:a="http://schemas.openxmlformats.org/drawingml/2006/main" xmlns:p="http://schemas.openxmlformats.org/presentationml/2006/main" xmlns:r="http://schemas.openxmlformats.org/officeDocument/2006/relationships">
-  <p:cSld>
-    <p:spTree>
-      <p:nvGrpSpPr>
-        <p:cNvPr id="1" name=""/>
-        <p:cNvGrpSpPr/>
-        <p:nvPr/>
-      </p:nvGrpSpPr>
-      <p:grpSpPr/>
-      <p:sp>
-        <p:nvSpPr>
-          <p:cNvPr id="2" name="TextBox 1"/>
-          <p:cNvSpPr txBox="1"/>
-          <p:nvPr/>
-        </p:nvSpPr>
-        <p:spPr>
-          <a:xfrm>
-            <a:off x="457200" y="274320"/>
-            <a:ext cx="8229600" cy="640080"/>
-          </a:xfrm>
-          <a:prstGeom prst="rect">
-            <a:avLst/>
-          </a:prstGeom>
-          <a:noFill/>
-        </p:spPr>
-        <p:txBody>
-          <a:bodyPr wrap="none">
-            <a:spAutoFit/>
-          </a:bodyPr>
-          <a:lstStyle/>
-          <a:p>
-            <a:pPr>
-              <a:defRPr sz="4000" b="1">
-                <a:solidFill>
-                  <a:srgbClr val="1F4E79"/>
-                </a:solidFill>
-              </a:defRPr>
-            </a:pPr>
-            <a:r>
-              <a:t>Key Findings from v0 Analysis</a:t>
-            </a:r>
-          </a:p>
-        </p:txBody>
-      </p:sp>
-      <p:sp>
-        <p:nvSpPr>
-          <p:cNvPr id="3" name="TextBox 2"/>
-          <p:cNvSpPr txBox="1"/>
-          <p:nvPr/>
-        </p:nvSpPr>
-        <p:spPr>
-          <a:xfrm>
-            <a:off x="640080" y="1097280"/>
-            <a:ext cx="7863840" cy="5303520"/>
-          </a:xfrm>
-          <a:prstGeom prst="rect">
-            <a:avLst/>
-          </a:prstGeom>
-          <a:noFill/>
-        </p:spPr>
-        <p:txBody>
-          <a:bodyPr wrap="square">
-            <a:spAutoFit/>
-          </a:bodyPr>
-          <a:lstStyle/>
-          <a:p>
-            <a:pPr>
-              <a:spcBef>
-                <a:spcPts val="600"/>
-              </a:spcBef>
-              <a:spcAft>
-                <a:spcPts val="300"/>
-              </a:spcAft>
-              <a:defRPr sz="1600" b="1">
-                <a:solidFill>
-                  <a:srgbClr val="1F4E79"/>
-                </a:solidFill>
-              </a:defRPr>
-            </a:pPr>
-            <a:r>
-              <a:t>Finding 1: Production Growth</a:t>
-            </a:r>
-          </a:p>
-          <a:p>
-            <a:pPr>
-              <a:spcBef>
-                <a:spcPts val="600"/>
-              </a:spcBef>
-              <a:spcAft>
-                <a:spcPts val="300"/>
-              </a:spcAft>
-              <a:defRPr sz="1400" b="0">
-                <a:solidFill>
-                  <a:srgbClr val="404040"/>
-                </a:solidFill>
-              </a:defRPr>
-            </a:pPr>
-            <a:r>
-              <a:t>Movie production has increased dramatically over time</a:t>
-            </a:r>
-          </a:p>
-          <a:p>
-            <a:pPr>
-              <a:spcBef>
-                <a:spcPts val="600"/>
-              </a:spcBef>
-              <a:spcAft>
-                <a:spcPts val="300"/>
-              </a:spcAft>
-              <a:defRPr sz="1400" b="0">
-                <a:solidFill>
-                  <a:srgbClr val="404040"/>
-                </a:solidFill>
-              </a:defRPr>
-            </a:pPr>
-            <a:r>
-              <a:t>More movies in recent decades than in 1950s-1980s</a:t>
-            </a:r>
-          </a:p>
-          <a:p>
-            <a:pPr>
-              <a:spcBef>
-                <a:spcPts val="600"/>
-              </a:spcBef>
-              <a:spcAft>
-                <a:spcPts val="300"/>
-              </a:spcAft>
-              <a:defRPr sz="1400" b="0">
-                <a:solidFill>
-                  <a:srgbClr val="404040"/>
-                </a:solidFill>
-              </a:defRPr>
-            </a:pPr>
-          </a:p>
-          <a:p>
-            <a:pPr>
-              <a:spcBef>
-                <a:spcPts val="600"/>
-              </a:spcBef>
-              <a:spcAft>
-                <a:spcPts val="300"/>
-              </a:spcAft>
-              <a:defRPr sz="1600" b="1">
-                <a:solidFill>
-                  <a:srgbClr val="1F4E79"/>
-                </a:solidFill>
-              </a:defRPr>
-            </a:pPr>
-            <a:r>
-              <a:t>Finding 2: Genre Distribution</a:t>
-            </a:r>
-          </a:p>
-          <a:p>
-            <a:pPr>
-              <a:spcBef>
-                <a:spcPts val="600"/>
-              </a:spcBef>
-              <a:spcAft>
-                <a:spcPts val="300"/>
-              </a:spcAft>
-              <a:defRPr sz="1400" b="0">
-                <a:solidFill>
-                  <a:srgbClr val="404040"/>
-                </a:solidFill>
-              </a:defRPr>
-            </a:pPr>
-            <a:r>
-              <a:t>Some genres appear much more frequently than others</a:t>
-            </a:r>
-          </a:p>
-          <a:p>
-            <a:pPr>
-              <a:spcBef>
-                <a:spcPts val="600"/>
-              </a:spcBef>
-              <a:spcAft>
-                <a:spcPts val="300"/>
-              </a:spcAft>
-              <a:defRPr sz="1400" b="0">
-                <a:solidFill>
-                  <a:srgbClr val="404040"/>
-                </a:solidFill>
-              </a:defRPr>
-            </a:pPr>
-            <a:r>
-              <a:t>Drama dominates, followed by comedy and action</a:t>
-            </a:r>
-          </a:p>
-          <a:p>
-            <a:pPr>
-              <a:spcBef>
-                <a:spcPts val="600"/>
-              </a:spcBef>
-              <a:spcAft>
-                <a:spcPts val="300"/>
-              </a:spcAft>
-              <a:defRPr sz="1400" b="0">
-                <a:solidFill>
-                  <a:srgbClr val="404040"/>
-                </a:solidFill>
-              </a:defRPr>
-            </a:pPr>
-          </a:p>
-          <a:p>
-            <a:pPr>
-              <a:spcBef>
-                <a:spcPts val="600"/>
-              </a:spcBef>
-              <a:spcAft>
-                <a:spcPts val="300"/>
-              </a:spcAft>
-              <a:defRPr sz="1600" b="1">
-                <a:solidFill>
-                  <a:srgbClr val="1F4E79"/>
-                </a:solidFill>
-              </a:defRPr>
-            </a:pPr>
-            <a:r>
-              <a:t>Finding 3: Rating Consistency</a:t>
-            </a:r>
-          </a:p>
-          <a:p>
-            <a:pPr>
-              <a:spcBef>
-                <a:spcPts val="600"/>
-              </a:spcBef>
-              <a:spcAft>
-                <a:spcPts val="300"/>
-              </a:spcAft>
-              <a:defRPr sz="1400" b="0">
-                <a:solidFill>
-                  <a:srgbClr val="404040"/>
-                </a:solidFill>
-              </a:defRPr>
-            </a:pPr>
-            <a:r>
-              <a:t>Average ratings remain relatively stable across decades</a:t>
-            </a:r>
-          </a:p>
-          <a:p>
-            <a:pPr>
-              <a:spcBef>
-                <a:spcPts val="600"/>
-              </a:spcBef>
-              <a:spcAft>
-                <a:spcPts val="300"/>
-              </a:spcAft>
-              <a:defRPr sz="1400" b="0">
-                <a:solidFill>
-                  <a:srgbClr val="404040"/>
-                </a:solidFill>
-              </a:defRPr>
-            </a:pPr>
-            <a:r>
-              <a:t>Slight variations exist but no major trend</a:t>
-            </a:r>
-          </a:p>
-        </p:txBody>
-      </p:sp>
-    </p:spTree>
-  </p:cSld>
-  <p:clrMapOvr>
-    <a:masterClrMapping/>
-  </p:clrMapOvr>
-</p:sld>
-</file>
-
-<file path=ppt/slides/slide15.xml><?xml version="1.0" encoding="utf-8"?>
-<p:sld xmlns:a="http://schemas.openxmlformats.org/drawingml/2006/main" xmlns:p="http://schemas.openxmlformats.org/presentationml/2006/main" xmlns:r="http://schemas.openxmlformats.org/officeDocument/2006/relationships">
-  <p:cSld>
-    <p:spTree>
-      <p:nvGrpSpPr>
-        <p:cNvPr id="1" name=""/>
-        <p:cNvGrpSpPr/>
-        <p:nvPr/>
-      </p:nvGrpSpPr>
-      <p:grpSpPr/>
-      <p:sp>
-        <p:nvSpPr>
-          <p:cNvPr id="2" name="TextBox 1"/>
-          <p:cNvSpPr txBox="1"/>
-          <p:nvPr/>
-        </p:nvSpPr>
-        <p:spPr>
-          <a:xfrm>
-            <a:off x="457200" y="274320"/>
-            <a:ext cx="8229600" cy="640080"/>
-          </a:xfrm>
-          <a:prstGeom prst="rect">
-            <a:avLst/>
-          </a:prstGeom>
-          <a:noFill/>
-        </p:spPr>
-        <p:txBody>
-          <a:bodyPr wrap="none">
-            <a:spAutoFit/>
-          </a:bodyPr>
-          <a:lstStyle/>
-          <a:p>
-            <a:pPr>
-              <a:defRPr sz="4000" b="1">
-                <a:solidFill>
-                  <a:srgbClr val="1F4E79"/>
-                </a:solidFill>
-              </a:defRPr>
-            </a:pPr>
-            <a:r>
-              <a:t>Additional Observations</a:t>
-            </a:r>
-          </a:p>
-        </p:txBody>
-      </p:sp>
-      <p:sp>
-        <p:nvSpPr>
-          <p:cNvPr id="3" name="TextBox 2"/>
-          <p:cNvSpPr txBox="1"/>
-          <p:nvPr/>
-        </p:nvSpPr>
-        <p:spPr>
-          <a:xfrm>
-            <a:off x="640080" y="1097280"/>
-            <a:ext cx="7863840" cy="5303520"/>
-          </a:xfrm>
-          <a:prstGeom prst="rect">
-            <a:avLst/>
-          </a:prstGeom>
-          <a:noFill/>
-        </p:spPr>
-        <p:txBody>
-          <a:bodyPr wrap="square">
-            <a:spAutoFit/>
-          </a:bodyPr>
-          <a:lstStyle/>
-          <a:p>
-            <a:pPr>
-              <a:spcBef>
-                <a:spcPts val="600"/>
-              </a:spcBef>
-              <a:spcAft>
-                <a:spcPts val="300"/>
-              </a:spcAft>
-              <a:defRPr sz="1600" b="1">
-                <a:solidFill>
-                  <a:srgbClr val="1F4E79"/>
-                </a:solidFill>
-              </a:defRPr>
-            </a:pPr>
-            <a:r>
-              <a:t>Finding 4: Votes Influence Stability</a:t>
-            </a:r>
-          </a:p>
-          <a:p>
-            <a:pPr>
-              <a:spcBef>
-                <a:spcPts val="600"/>
-              </a:spcBef>
-              <a:spcAft>
-                <a:spcPts val="300"/>
-              </a:spcAft>
-              <a:defRPr sz="1400" b="0">
-                <a:solidFill>
-                  <a:srgbClr val="404040"/>
-                </a:solidFill>
-              </a:defRPr>
-            </a:pPr>
-            <a:r>
-              <a:t>Movies with more votes tend to have more consistent ratings</a:t>
-            </a:r>
-          </a:p>
-          <a:p>
-            <a:pPr>
-              <a:spcBef>
-                <a:spcPts val="600"/>
-              </a:spcBef>
-              <a:spcAft>
-                <a:spcPts val="300"/>
-              </a:spcAft>
-              <a:defRPr sz="1400" b="0">
-                <a:solidFill>
-                  <a:srgbClr val="404040"/>
-                </a:solidFill>
-              </a:defRPr>
-            </a:pPr>
-            <a:r>
-              <a:t>Low-vote movies show extreme ratings (very high or very low)</a:t>
-            </a:r>
-          </a:p>
-          <a:p>
-            <a:pPr>
-              <a:spcBef>
-                <a:spcPts val="600"/>
-              </a:spcBef>
-              <a:spcAft>
-                <a:spcPts val="300"/>
-              </a:spcAft>
-              <a:defRPr sz="1400" b="0">
-                <a:solidFill>
-                  <a:srgbClr val="404040"/>
-                </a:solidFill>
-              </a:defRPr>
-            </a:pPr>
-          </a:p>
-          <a:p>
-            <a:pPr>
-              <a:spcBef>
-                <a:spcPts val="600"/>
-              </a:spcBef>
-              <a:spcAft>
-                <a:spcPts val="300"/>
-              </a:spcAft>
-              <a:defRPr sz="1600" b="1">
-                <a:solidFill>
-                  <a:srgbClr val="1F4E79"/>
-                </a:solidFill>
-              </a:defRPr>
-            </a:pPr>
-            <a:r>
-              <a:t>Finding 5: Quality Perception</a:t>
-            </a:r>
-          </a:p>
-          <a:p>
-            <a:pPr>
-              <a:spcBef>
-                <a:spcPts val="600"/>
-              </a:spcBef>
-              <a:spcAft>
-                <a:spcPts val="300"/>
-              </a:spcAft>
-              <a:defRPr sz="1400" b="0">
-                <a:solidFill>
-                  <a:srgbClr val="404040"/>
-                </a:solidFill>
-              </a:defRPr>
-            </a:pPr>
-            <a:r>
-              <a:t>Top-rated movies cluster around 8.0-9.0 range</a:t>
-            </a:r>
-          </a:p>
-          <a:p>
-            <a:pPr>
-              <a:spcBef>
-                <a:spcPts val="600"/>
-              </a:spcBef>
-              <a:spcAft>
-                <a:spcPts val="300"/>
-              </a:spcAft>
-              <a:defRPr sz="1400" b="0">
-                <a:solidFill>
-                  <a:srgbClr val="404040"/>
-                </a:solidFill>
-              </a:defRPr>
-            </a:pPr>
-            <a:r>
-              <a:t>Most movies fall in 6.0-7.0 average rating range</a:t>
-            </a:r>
-          </a:p>
-          <a:p>
-            <a:pPr>
-              <a:spcBef>
-                <a:spcPts val="600"/>
-              </a:spcBef>
-              <a:spcAft>
-                <a:spcPts val="300"/>
-              </a:spcAft>
-              <a:defRPr sz="1400" b="0">
-                <a:solidFill>
-                  <a:srgbClr val="404040"/>
-                </a:solidFill>
-              </a:defRPr>
-            </a:pPr>
-          </a:p>
-          <a:p>
-            <a:pPr>
-              <a:spcBef>
-                <a:spcPts val="600"/>
-              </a:spcBef>
-              <a:spcAft>
-                <a:spcPts val="300"/>
-              </a:spcAft>
-              <a:defRPr sz="1600" b="1">
-                <a:solidFill>
-                  <a:srgbClr val="1F4E79"/>
-                </a:solidFill>
-              </a:defRPr>
-            </a:pPr>
-            <a:r>
-              <a:t>Finding 6: Dataset Characteristics</a:t>
-            </a:r>
-          </a:p>
-          <a:p>
-            <a:pPr>
-              <a:spcBef>
-                <a:spcPts val="600"/>
-              </a:spcBef>
-              <a:spcAft>
-                <a:spcPts val="300"/>
-              </a:spcAft>
-              <a:defRPr sz="1400" b="0">
-                <a:solidFill>
-                  <a:srgbClr val="404040"/>
-                </a:solidFill>
-              </a:defRPr>
-            </a:pPr>
-            <a:r>
-              <a:t>Data shows typical Big Data challenges: volume, variety, veracity</a:t>
-            </a:r>
-          </a:p>
-        </p:txBody>
-      </p:sp>
-    </p:spTree>
-  </p:cSld>
-  <p:clrMapOvr>
-    <a:masterClrMapping/>
-  </p:clrMapOvr>
-</p:sld>
-</file>
-
-<file path=ppt/slides/slide16.xml><?xml version="1.0" encoding="utf-8"?>
-<p:sld xmlns:a="http://schemas.openxmlformats.org/drawingml/2006/main" xmlns:p="http://schemas.openxmlformats.org/presentationml/2006/main" xmlns:r="http://schemas.openxmlformats.org/officeDocument/2006/relationships">
-  <p:cSld>
-    <p:spTree>
-      <p:nvGrpSpPr>
-        <p:cNvPr id="1" name=""/>
-        <p:cNvGrpSpPr/>
-        <p:nvPr/>
-      </p:nvGrpSpPr>
-      <p:grpSpPr/>
-      <p:sp>
-        <p:nvSpPr>
-          <p:cNvPr id="2" name="TextBox 1"/>
-          <p:cNvSpPr txBox="1"/>
-          <p:nvPr/>
-        </p:nvSpPr>
-        <p:spPr>
-          <a:xfrm>
-            <a:off x="457200" y="274320"/>
-            <a:ext cx="8229600" cy="640080"/>
-          </a:xfrm>
-          <a:prstGeom prst="rect">
-            <a:avLst/>
-          </a:prstGeom>
-          <a:noFill/>
-        </p:spPr>
-        <p:txBody>
-          <a:bodyPr wrap="none">
-            <a:spAutoFit/>
-          </a:bodyPr>
-          <a:lstStyle/>
-          <a:p>
-            <a:pPr>
-              <a:defRPr sz="4000" b="1">
-                <a:solidFill>
-                  <a:srgbClr val="1F4E79"/>
-                </a:solidFill>
-              </a:defRPr>
-            </a:pPr>
-            <a:r>
-              <a:t>Limitations &amp; Future Work</a:t>
-            </a:r>
-          </a:p>
-        </p:txBody>
-      </p:sp>
-      <p:sp>
-        <p:nvSpPr>
-          <p:cNvPr id="3" name="TextBox 2"/>
-          <p:cNvSpPr txBox="1"/>
-          <p:nvPr/>
-        </p:nvSpPr>
-        <p:spPr>
-          <a:xfrm>
-            <a:off x="640080" y="1097280"/>
-            <a:ext cx="7863840" cy="5303520"/>
-          </a:xfrm>
-          <a:prstGeom prst="rect">
-            <a:avLst/>
-          </a:prstGeom>
-          <a:noFill/>
-        </p:spPr>
-        <p:txBody>
-          <a:bodyPr wrap="square">
-            <a:spAutoFit/>
-          </a:bodyPr>
-          <a:lstStyle/>
-          <a:p>
-            <a:pPr>
-              <a:spcBef>
-                <a:spcPts val="600"/>
-              </a:spcBef>
-              <a:spcAft>
-                <a:spcPts val="300"/>
-              </a:spcAft>
-              <a:defRPr sz="1600" b="1">
-                <a:solidFill>
-                  <a:srgbClr val="1F4E79"/>
-                </a:solidFill>
-              </a:defRPr>
-            </a:pPr>
-            <a:r>
-              <a:t>Limitations of v0</a:t>
-            </a:r>
-          </a:p>
-          <a:p>
-            <a:pPr>
-              <a:spcBef>
-                <a:spcPts val="600"/>
-              </a:spcBef>
-              <a:spcAft>
-                <a:spcPts val="300"/>
-              </a:spcAft>
-              <a:defRPr sz="1400" b="0">
-                <a:solidFill>
-                  <a:srgbClr val="404040"/>
-                </a:solidFill>
-              </a:defRPr>
-            </a:pPr>
-            <a:r>
-              <a:t>No data quality filters (low-vote movies treated same as high-vote)</a:t>
-            </a:r>
-          </a:p>
-          <a:p>
-            <a:pPr>
-              <a:spcBef>
-                <a:spcPts val="600"/>
-              </a:spcBef>
-              <a:spcAft>
-                <a:spcPts val="300"/>
-              </a:spcAft>
-              <a:defRPr sz="1400" b="0">
-                <a:solidFill>
-                  <a:srgbClr val="404040"/>
-                </a:solidFill>
-              </a:defRPr>
-            </a:pPr>
-            <a:r>
-              <a:t>No predictive modeling</a:t>
-            </a:r>
-          </a:p>
-          <a:p>
-            <a:pPr>
-              <a:spcBef>
-                <a:spcPts val="600"/>
-              </a:spcBef>
-              <a:spcAft>
-                <a:spcPts val="300"/>
-              </a:spcAft>
-              <a:defRPr sz="1400" b="0">
-                <a:solidFill>
-                  <a:srgbClr val="404040"/>
-                </a:solidFill>
-              </a:defRPr>
-            </a:pPr>
-            <a:r>
-              <a:t>Basic exploratory analysis only</a:t>
-            </a:r>
-          </a:p>
-          <a:p>
-            <a:pPr>
-              <a:spcBef>
-                <a:spcPts val="600"/>
-              </a:spcBef>
-              <a:spcAft>
-                <a:spcPts val="300"/>
-              </a:spcAft>
-              <a:defRPr sz="1400" b="0">
-                <a:solidFill>
-                  <a:srgbClr val="404040"/>
-                </a:solidFill>
-              </a:defRPr>
-            </a:pPr>
-          </a:p>
-          <a:p>
-            <a:pPr>
-              <a:spcBef>
-                <a:spcPts val="600"/>
-              </a:spcBef>
-              <a:spcAft>
-                <a:spcPts val="300"/>
-              </a:spcAft>
-              <a:defRPr sz="1600" b="1">
-                <a:solidFill>
-                  <a:srgbClr val="1F4E79"/>
-                </a:solidFill>
-              </a:defRPr>
-            </a:pPr>
-            <a:r>
-              <a:t>What Could Be Added (v1, v2, ...)</a:t>
-            </a:r>
-          </a:p>
-          <a:p>
-            <a:pPr>
-              <a:spcBef>
-                <a:spcPts val="600"/>
-              </a:spcBef>
-              <a:spcAft>
-                <a:spcPts val="300"/>
-              </a:spcAft>
-              <a:defRPr sz="1400" b="0">
-                <a:solidFill>
-                  <a:srgbClr val="404040"/>
-                </a:solidFill>
-              </a:defRPr>
-            </a:pPr>
-            <a:r>
-              <a:t>Filter by vote count to improve reliability</a:t>
-            </a:r>
-          </a:p>
-          <a:p>
-            <a:pPr>
-              <a:spcBef>
-                <a:spcPts val="600"/>
-              </a:spcBef>
-              <a:spcAft>
-                <a:spcPts val="300"/>
-              </a:spcAft>
-              <a:defRPr sz="1400" b="0">
-                <a:solidFill>
-                  <a:srgbClr val="404040"/>
-                </a:solidFill>
-              </a:defRPr>
-            </a:pPr>
-            <a:r>
-              <a:t>Statistical analysis and hypothesis testing</a:t>
-            </a:r>
-          </a:p>
-          <a:p>
-            <a:pPr>
-              <a:spcBef>
-                <a:spcPts val="600"/>
-              </a:spcBef>
-              <a:spcAft>
-                <a:spcPts val="300"/>
-              </a:spcAft>
-              <a:defRPr sz="1400" b="0">
-                <a:solidFill>
-                  <a:srgbClr val="404040"/>
-                </a:solidFill>
-              </a:defRPr>
-            </a:pPr>
-            <a:r>
-              <a:t>Predictive models to forecast ratings</a:t>
-            </a:r>
-          </a:p>
-          <a:p>
-            <a:pPr>
-              <a:spcBef>
-                <a:spcPts val="600"/>
-              </a:spcBef>
-              <a:spcAft>
-                <a:spcPts val="300"/>
-              </a:spcAft>
-              <a:defRPr sz="1400" b="0">
-                <a:solidFill>
-                  <a:srgbClr val="404040"/>
-                </a:solidFill>
-              </a:defRPr>
-            </a:pPr>
-            <a:r>
-              <a:t>Investment strategy recommendations</a:t>
-            </a:r>
-          </a:p>
-        </p:txBody>
-      </p:sp>
-    </p:spTree>
-  </p:cSld>
-  <p:clrMapOvr>
-    <a:masterClrMapping/>
-  </p:clrMapOvr>
-</p:sld>
-</file>
-
-<file path=ppt/slides/slide17.xml><?xml version="1.0" encoding="utf-8"?>
-<p:sld xmlns:a="http://schemas.openxmlformats.org/drawingml/2006/main" xmlns:p="http://schemas.openxmlformats.org/presentationml/2006/main" xmlns:r="http://schemas.openxmlformats.org/officeDocument/2006/relationships">
-  <p:cSld>
-    <p:spTree>
-      <p:nvGrpSpPr>
-        <p:cNvPr id="1" name=""/>
-        <p:cNvGrpSpPr/>
-        <p:nvPr/>
-      </p:nvGrpSpPr>
-      <p:grpSpPr/>
-      <p:sp>
-        <p:nvSpPr>
-          <p:cNvPr id="2" name="TextBox 1"/>
-          <p:cNvSpPr txBox="1"/>
-          <p:nvPr/>
-        </p:nvSpPr>
-        <p:spPr>
-          <a:xfrm>
-            <a:off x="457200" y="274320"/>
-            <a:ext cx="8229600" cy="640080"/>
-          </a:xfrm>
-          <a:prstGeom prst="rect">
-            <a:avLst/>
-          </a:prstGeom>
-          <a:noFill/>
-        </p:spPr>
-        <p:txBody>
-          <a:bodyPr wrap="none">
-            <a:spAutoFit/>
-          </a:bodyPr>
-          <a:lstStyle/>
-          <a:p>
-            <a:pPr>
-              <a:defRPr sz="4000" b="1">
-                <a:solidFill>
-                  <a:srgbClr val="1F4E79"/>
-                </a:solidFill>
-              </a:defRPr>
-            </a:pPr>
-            <a:r>
-              <a:t>Conclusion</a:t>
-            </a:r>
-          </a:p>
-        </p:txBody>
-      </p:sp>
-      <p:sp>
-        <p:nvSpPr>
-          <p:cNvPr id="3" name="TextBox 2"/>
-          <p:cNvSpPr txBox="1"/>
-          <p:nvPr/>
-        </p:nvSpPr>
-        <p:spPr>
-          <a:xfrm>
-            <a:off x="640080" y="1097280"/>
-            <a:ext cx="7863840" cy="5303520"/>
-          </a:xfrm>
-          <a:prstGeom prst="rect">
-            <a:avLst/>
-          </a:prstGeom>
-          <a:noFill/>
-        </p:spPr>
-        <p:txBody>
-          <a:bodyPr wrap="square">
-            <a:spAutoFit/>
-          </a:bodyPr>
-          <a:lstStyle/>
-          <a:p>
-            <a:pPr>
-              <a:spcBef>
-                <a:spcPts val="600"/>
-              </a:spcBef>
-              <a:spcAft>
-                <a:spcPts val="300"/>
-              </a:spcAft>
-              <a:defRPr sz="1600" b="1">
-                <a:solidFill>
-                  <a:srgbClr val="1F4E79"/>
-                </a:solidFill>
-              </a:defRPr>
-            </a:pPr>
-            <a:r>
-              <a:t>Accomplishment</a:t>
-            </a:r>
-          </a:p>
-          <a:p>
-            <a:pPr>
-              <a:spcBef>
-                <a:spcPts val="600"/>
-              </a:spcBef>
-              <a:spcAft>
-                <a:spcPts val="300"/>
-              </a:spcAft>
-              <a:defRPr sz="1400" b="0">
-                <a:solidFill>
-                  <a:srgbClr val="404040"/>
-                </a:solidFill>
-              </a:defRPr>
-            </a:pPr>
-            <a:r>
-              <a:t>Successfully processed 12 million+ records using Databricks</a:t>
-            </a:r>
-          </a:p>
-          <a:p>
-            <a:pPr>
-              <a:spcBef>
-                <a:spcPts val="600"/>
-              </a:spcBef>
-              <a:spcAft>
-                <a:spcPts val="300"/>
-              </a:spcAft>
-              <a:defRPr sz="1400" b="0">
-                <a:solidFill>
-                  <a:srgbClr val="404040"/>
-                </a:solidFill>
-              </a:defRPr>
-            </a:pPr>
-            <a:r>
-              <a:t>Identified 6 key trends in movie industry data</a:t>
-            </a:r>
-          </a:p>
-          <a:p>
-            <a:pPr>
-              <a:spcBef>
-                <a:spcPts val="600"/>
-              </a:spcBef>
-              <a:spcAft>
-                <a:spcPts val="300"/>
-              </a:spcAft>
-              <a:defRPr sz="1400" b="0">
-                <a:solidFill>
-                  <a:srgbClr val="404040"/>
-                </a:solidFill>
-              </a:defRPr>
-            </a:pPr>
-            <a:r>
-              <a:t>Demonstrated Big Data tools work for real problems</a:t>
-            </a:r>
-          </a:p>
-          <a:p>
-            <a:pPr>
-              <a:spcBef>
-                <a:spcPts val="600"/>
-              </a:spcBef>
-              <a:spcAft>
-                <a:spcPts val="300"/>
-              </a:spcAft>
-              <a:defRPr sz="1400" b="0">
-                <a:solidFill>
-                  <a:srgbClr val="404040"/>
-                </a:solidFill>
-              </a:defRPr>
-            </a:pPr>
-          </a:p>
-          <a:p>
-            <a:pPr>
-              <a:spcBef>
-                <a:spcPts val="600"/>
-              </a:spcBef>
-              <a:spcAft>
-                <a:spcPts val="300"/>
-              </a:spcAft>
-              <a:defRPr sz="1600" b="1">
-                <a:solidFill>
-                  <a:srgbClr val="1F4E79"/>
-                </a:solidFill>
-              </a:defRPr>
-            </a:pPr>
-            <a:r>
-              <a:t>Learning Outcome</a:t>
-            </a:r>
-          </a:p>
-          <a:p>
-            <a:pPr>
-              <a:spcBef>
-                <a:spcPts val="600"/>
-              </a:spcBef>
-              <a:spcAft>
-                <a:spcPts val="300"/>
-              </a:spcAft>
-              <a:defRPr sz="1400" b="0">
-                <a:solidFill>
-                  <a:srgbClr val="404040"/>
-                </a:solidFill>
-              </a:defRPr>
-            </a:pPr>
-            <a:r>
-              <a:t>Data cleaning and transformation essential for analysis</a:t>
-            </a:r>
-          </a:p>
-          <a:p>
-            <a:pPr>
-              <a:spcBef>
-                <a:spcPts val="600"/>
-              </a:spcBef>
-              <a:spcAft>
-                <a:spcPts val="300"/>
-              </a:spcAft>
-              <a:defRPr sz="1400" b="0">
-                <a:solidFill>
-                  <a:srgbClr val="404040"/>
-                </a:solidFill>
-              </a:defRPr>
-            </a:pPr>
-            <a:r>
-              <a:t>Multiple perspectives (by year, by genre, by rating) reveal different insights</a:t>
-            </a:r>
-          </a:p>
-          <a:p>
-            <a:pPr>
-              <a:spcBef>
-                <a:spcPts val="600"/>
-              </a:spcBef>
-              <a:spcAft>
-                <a:spcPts val="300"/>
-              </a:spcAft>
-              <a:defRPr sz="1400" b="0">
-                <a:solidFill>
-                  <a:srgbClr val="404040"/>
-                </a:solidFill>
-              </a:defRPr>
-            </a:pPr>
-            <a:r>
-              <a:t>Raw data requires preparation before meaningful conclusions</a:t>
-            </a:r>
-          </a:p>
-        </p:txBody>
-      </p:sp>
-    </p:spTree>
-  </p:cSld>
-  <p:clrMapOvr>
-    <a:masterClrMapping/>
-  </p:clrMapOvr>
-</p:sld>
-</file>
-
-<file path=ppt/slides/slide18.xml><?xml version="1.0" encoding="utf-8"?>
-<p:sld xmlns:a="http://schemas.openxmlformats.org/drawingml/2006/main" xmlns:p="http://schemas.openxmlformats.org/presentationml/2006/main" xmlns:r="http://schemas.openxmlformats.org/officeDocument/2006/relationships">
-  <p:cSld>
-    <p:spTree>
-      <p:nvGrpSpPr>
-        <p:cNvPr id="1" name=""/>
-        <p:cNvGrpSpPr/>
-        <p:nvPr/>
-      </p:nvGrpSpPr>
-      <p:grpSpPr/>
-      <p:sp>
-        <p:nvSpPr>
-          <p:cNvPr id="2" name="TextBox 1"/>
-          <p:cNvSpPr txBox="1"/>
-          <p:nvPr/>
-        </p:nvSpPr>
-        <p:spPr>
-          <a:xfrm>
-            <a:off x="457200" y="274320"/>
-            <a:ext cx="8229600" cy="640080"/>
-          </a:xfrm>
-          <a:prstGeom prst="rect">
-            <a:avLst/>
-          </a:prstGeom>
-          <a:noFill/>
-        </p:spPr>
-        <p:txBody>
-          <a:bodyPr wrap="none">
-            <a:spAutoFit/>
-          </a:bodyPr>
-          <a:lstStyle/>
-          <a:p>
-            <a:pPr>
-              <a:defRPr sz="4000" b="1">
-                <a:solidFill>
-                  <a:srgbClr val="1F4E79"/>
-                </a:solidFill>
-              </a:defRPr>
-            </a:pPr>
-            <a:r>
-              <a:t>v0 Summary: 12 Chunks of Code</a:t>
-            </a:r>
-          </a:p>
-        </p:txBody>
-      </p:sp>
-      <p:sp>
-        <p:nvSpPr>
-          <p:cNvPr id="3" name="TextBox 2"/>
-          <p:cNvSpPr txBox="1"/>
-          <p:nvPr/>
-        </p:nvSpPr>
-        <p:spPr>
-          <a:xfrm>
-            <a:off x="640080" y="1097280"/>
-            <a:ext cx="7863840" cy="5303520"/>
-          </a:xfrm>
-          <a:prstGeom prst="rect">
-            <a:avLst/>
-          </a:prstGeom>
-          <a:noFill/>
-        </p:spPr>
-        <p:txBody>
-          <a:bodyPr wrap="square">
-            <a:spAutoFit/>
-          </a:bodyPr>
-          <a:lstStyle/>
-          <a:p>
-            <a:pPr>
-              <a:spcBef>
-                <a:spcPts val="600"/>
-              </a:spcBef>
-              <a:spcAft>
-                <a:spcPts val="300"/>
-              </a:spcAft>
-              <a:defRPr sz="1600" b="1">
-                <a:solidFill>
-                  <a:srgbClr val="1F4E79"/>
-                </a:solidFill>
-              </a:defRPr>
-            </a:pPr>
-            <a:r>
-              <a:t>Chunks 01-03: Loading &amp; Cleaning</a:t>
-            </a:r>
-          </a:p>
-          <a:p>
-            <a:pPr>
-              <a:spcBef>
-                <a:spcPts val="600"/>
-              </a:spcBef>
-              <a:spcAft>
-                <a:spcPts val="300"/>
-              </a:spcAft>
-              <a:defRPr sz="1400" b="0">
-                <a:solidFill>
-                  <a:srgbClr val="404040"/>
-                </a:solidFill>
-              </a:defRPr>
-            </a:pPr>
-            <a:r>
-              <a:t>Load 12M records, replace \N with NULL</a:t>
-            </a:r>
-          </a:p>
-          <a:p>
-            <a:pPr>
-              <a:spcBef>
-                <a:spcPts val="600"/>
-              </a:spcBef>
-              <a:spcAft>
-                <a:spcPts val="300"/>
-              </a:spcAft>
-              <a:defRPr sz="1400" b="0">
-                <a:solidFill>
-                  <a:srgbClr val="404040"/>
-                </a:solidFill>
-              </a:defRPr>
-            </a:pPr>
-          </a:p>
-          <a:p>
-            <a:pPr>
-              <a:spcBef>
-                <a:spcPts val="600"/>
-              </a:spcBef>
-              <a:spcAft>
-                <a:spcPts val="300"/>
-              </a:spcAft>
-              <a:defRPr sz="1600" b="1">
-                <a:solidFill>
-                  <a:srgbClr val="1F4E79"/>
-                </a:solidFill>
-              </a:defRPr>
-            </a:pPr>
-            <a:r>
-              <a:t>Chunks 04-06: Integration &amp; Transformation</a:t>
-            </a:r>
-          </a:p>
-          <a:p>
-            <a:pPr>
-              <a:spcBef>
-                <a:spcPts val="600"/>
-              </a:spcBef>
-              <a:spcAft>
-                <a:spcPts val="300"/>
-              </a:spcAft>
-              <a:defRPr sz="1400" b="0">
-                <a:solidFill>
-                  <a:srgbClr val="404040"/>
-                </a:solidFill>
-              </a:defRPr>
-            </a:pPr>
-            <a:r>
-              <a:t>Join tables, filter to movies only, convert data types</a:t>
-            </a:r>
-          </a:p>
-          <a:p>
-            <a:pPr>
-              <a:spcBef>
-                <a:spcPts val="600"/>
-              </a:spcBef>
-              <a:spcAft>
-                <a:spcPts val="300"/>
-              </a:spcAft>
-              <a:defRPr sz="1400" b="0">
-                <a:solidFill>
-                  <a:srgbClr val="404040"/>
-                </a:solidFill>
-              </a:defRPr>
-            </a:pPr>
-          </a:p>
-          <a:p>
-            <a:pPr>
-              <a:spcBef>
-                <a:spcPts val="600"/>
-              </a:spcBef>
-              <a:spcAft>
-                <a:spcPts val="300"/>
-              </a:spcAft>
-              <a:defRPr sz="1600" b="1">
-                <a:solidFill>
-                  <a:srgbClr val="1F4E79"/>
-                </a:solidFill>
-              </a:defRPr>
-            </a:pPr>
-            <a:r>
-              <a:t>Chunks 07-12: Exploratory Analysis</a:t>
-            </a:r>
-          </a:p>
-          <a:p>
-            <a:pPr>
-              <a:spcBef>
-                <a:spcPts val="600"/>
-              </a:spcBef>
-              <a:spcAft>
-                <a:spcPts val="300"/>
-              </a:spcAft>
-              <a:defRPr sz="1400" b="0">
-                <a:solidFill>
-                  <a:srgbClr val="404040"/>
-                </a:solidFill>
-              </a:defRPr>
-            </a:pPr>
-            <a:r>
-              <a:t>6 different ways of looking at the data</a:t>
-            </a:r>
-          </a:p>
-          <a:p>
-            <a:pPr>
-              <a:spcBef>
-                <a:spcPts val="600"/>
-              </a:spcBef>
-              <a:spcAft>
-                <a:spcPts val="300"/>
-              </a:spcAft>
-              <a:defRPr sz="1400" b="0">
-                <a:solidFill>
-                  <a:srgbClr val="404040"/>
-                </a:solidFill>
-              </a:defRPr>
-            </a:pPr>
-            <a:r>
-              <a:t>Generated 6 visualizations showing key trends</a:t>
-            </a:r>
-          </a:p>
-          <a:p>
-            <a:pPr>
-              <a:spcBef>
-                <a:spcPts val="600"/>
-              </a:spcBef>
-              <a:spcAft>
-                <a:spcPts val="300"/>
-              </a:spcAft>
-              <a:defRPr sz="1400" b="0">
-                <a:solidFill>
-                  <a:srgbClr val="404040"/>
-                </a:solidFill>
-              </a:defRPr>
-            </a:pPr>
-          </a:p>
-          <a:p>
-            <a:pPr>
-              <a:spcBef>
-                <a:spcPts val="600"/>
-              </a:spcBef>
-              <a:spcAft>
-                <a:spcPts val="300"/>
-              </a:spcAft>
-              <a:defRPr sz="1600" b="1">
-                <a:solidFill>
-                  <a:srgbClr val="1F4E79"/>
-                </a:solidFill>
-              </a:defRPr>
-            </a:pPr>
-            <a:r>
-              <a:t>This is the Foundation</a:t>
-            </a:r>
-          </a:p>
-          <a:p>
-            <a:pPr>
-              <a:spcBef>
-                <a:spcPts val="600"/>
-              </a:spcBef>
-              <a:spcAft>
-                <a:spcPts val="300"/>
-              </a:spcAft>
-              <a:defRPr sz="1400" b="0">
-                <a:solidFill>
-                  <a:srgbClr val="404040"/>
-                </a:solidFill>
-              </a:defRPr>
-            </a:pPr>
-            <a:r>
-              <a:t>v0 provides the starting point for all future improvements</a:t>
-            </a:r>
-          </a:p>
-        </p:txBody>
-      </p:sp>
-    </p:spTree>
-  </p:cSld>
-  <p:clrMapOvr>
-    <a:masterClrMapping/>
-  </p:clrMapOvr>
-</p:sld>
-</file>
-
-<file path=ppt/slides/slide2.xml><?xml version="1.0" encoding="utf-8"?>
-<p:sld xmlns:a="http://schemas.openxmlformats.org/drawingml/2006/main" xmlns:p="http://schemas.openxmlformats.org/presentationml/2006/main" xmlns:r="http://schemas.openxmlformats.org/officeDocument/2006/relationships">
-  <p:cSld>
-    <p:spTree>
-      <p:nvGrpSpPr>
-        <p:cNvPr id="1" name=""/>
-        <p:cNvGrpSpPr/>
-        <p:nvPr/>
-      </p:nvGrpSpPr>
-      <p:grpSpPr/>
-      <p:sp>
-        <p:nvSpPr>
-          <p:cNvPr id="2" name="TextBox 1"/>
-          <p:cNvSpPr txBox="1"/>
-          <p:nvPr/>
-        </p:nvSpPr>
-        <p:spPr>
-          <a:xfrm>
-            <a:off x="457200" y="274320"/>
-            <a:ext cx="8229600" cy="640080"/>
-          </a:xfrm>
-          <a:prstGeom prst="rect">
-            <a:avLst/>
-          </a:prstGeom>
-          <a:noFill/>
-        </p:spPr>
-        <p:txBody>
-          <a:bodyPr wrap="none">
-            <a:spAutoFit/>
-          </a:bodyPr>
-          <a:lstStyle/>
-          <a:p>
-            <a:pPr>
-              <a:defRPr sz="4000" b="1">
-                <a:solidFill>
-                  <a:srgbClr val="1F4E79"/>
-                </a:solidFill>
-              </a:defRPr>
-            </a:pPr>
-            <a:r>
-              <a:t>Project Overview</a:t>
-            </a:r>
-          </a:p>
-        </p:txBody>
-      </p:sp>
-      <p:sp>
-        <p:nvSpPr>
-          <p:cNvPr id="3" name="TextBox 2"/>
-          <p:cNvSpPr txBox="1"/>
-          <p:nvPr/>
-        </p:nvSpPr>
-        <p:spPr>
-          <a:xfrm>
-            <a:off x="640080" y="1097280"/>
-            <a:ext cx="7863840" cy="5303520"/>
-          </a:xfrm>
-          <a:prstGeom prst="rect">
-            <a:avLst/>
-          </a:prstGeom>
-          <a:noFill/>
-        </p:spPr>
-        <p:txBody>
-          <a:bodyPr wrap="square">
-            <a:spAutoFit/>
-          </a:bodyPr>
-          <a:lstStyle/>
-          <a:p>
-            <a:pPr>
-              <a:spcBef>
-                <a:spcPts val="600"/>
-              </a:spcBef>
-              <a:spcAft>
-                <a:spcPts val="300"/>
-              </a:spcAft>
-              <a:defRPr sz="1600" b="1">
-                <a:solidFill>
-                  <a:srgbClr val="1F4E79"/>
-                </a:solidFill>
-              </a:defRPr>
-            </a:pPr>
-            <a:r>
-              <a:t>Objective</a:t>
-            </a:r>
-          </a:p>
-          <a:p>
-            <a:pPr>
-              <a:spcBef>
-                <a:spcPts val="600"/>
-              </a:spcBef>
-              <a:spcAft>
-                <a:spcPts val="300"/>
-              </a:spcAft>
-              <a:defRPr sz="1400" b="0">
-                <a:solidFill>
-                  <a:srgbClr val="404040"/>
-                </a:solidFill>
-              </a:defRPr>
-            </a:pPr>
-            <a:r>
-              <a:t>Analyze IMDb movie dataset to identify trends in movie production, ratings, and popularity</a:t>
-            </a:r>
-          </a:p>
-          <a:p>
-            <a:pPr>
-              <a:spcBef>
-                <a:spcPts val="600"/>
-              </a:spcBef>
-              <a:spcAft>
-                <a:spcPts val="300"/>
-              </a:spcAft>
-              <a:defRPr sz="1400" b="0">
-                <a:solidFill>
-                  <a:srgbClr val="404040"/>
-                </a:solidFill>
-              </a:defRPr>
-            </a:pPr>
-          </a:p>
-          <a:p>
-            <a:pPr>
-              <a:spcBef>
-                <a:spcPts val="600"/>
-              </a:spcBef>
-              <a:spcAft>
-                <a:spcPts val="300"/>
-              </a:spcAft>
-              <a:defRPr sz="1600" b="1">
-                <a:solidFill>
-                  <a:srgbClr val="1F4E79"/>
-                </a:solidFill>
-              </a:defRPr>
-            </a:pPr>
-            <a:r>
-              <a:t>Dataset Scope</a:t>
-            </a:r>
-          </a:p>
-          <a:p>
-            <a:pPr>
-              <a:spcBef>
-                <a:spcPts val="600"/>
-              </a:spcBef>
-              <a:spcAft>
-                <a:spcPts val="300"/>
-              </a:spcAft>
-              <a:defRPr sz="1400" b="0">
-                <a:solidFill>
-                  <a:srgbClr val="404040"/>
-                </a:solidFill>
-              </a:defRPr>
-            </a:pPr>
-            <a:r>
-              <a:t>12 million+ raw records (title_basics + title_ratings tables)</a:t>
-            </a:r>
-          </a:p>
-          <a:p>
-            <a:pPr>
-              <a:spcBef>
-                <a:spcPts val="600"/>
-              </a:spcBef>
-              <a:spcAft>
-                <a:spcPts val="300"/>
-              </a:spcAft>
-              <a:defRPr sz="1400" b="0">
-                <a:solidFill>
-                  <a:srgbClr val="404040"/>
-                </a:solidFill>
-              </a:defRPr>
-            </a:pPr>
-            <a:r>
-              <a:t>330,970 theatrical movies across 106 years (1920-2026)</a:t>
-            </a:r>
-          </a:p>
-          <a:p>
-            <a:pPr>
-              <a:spcBef>
-                <a:spcPts val="600"/>
-              </a:spcBef>
-              <a:spcAft>
-                <a:spcPts val="300"/>
-              </a:spcAft>
-              <a:defRPr sz="1400" b="0">
-                <a:solidFill>
-                  <a:srgbClr val="404040"/>
-                </a:solidFill>
-              </a:defRPr>
-            </a:pPr>
-          </a:p>
-          <a:p>
-            <a:pPr>
-              <a:spcBef>
-                <a:spcPts val="600"/>
-              </a:spcBef>
-              <a:spcAft>
-                <a:spcPts val="300"/>
-              </a:spcAft>
-              <a:defRPr sz="1600" b="1">
-                <a:solidFill>
-                  <a:srgbClr val="1F4E79"/>
-                </a:solidFill>
-              </a:defRPr>
-            </a:pPr>
-            <a:r>
-              <a:t>Tools &amp; Technology</a:t>
-            </a:r>
-          </a:p>
-          <a:p>
-            <a:pPr>
-              <a:spcBef>
-                <a:spcPts val="600"/>
-              </a:spcBef>
-              <a:spcAft>
-                <a:spcPts val="300"/>
-              </a:spcAft>
-              <a:defRPr sz="1400" b="0">
-                <a:solidFill>
-                  <a:srgbClr val="404040"/>
-                </a:solidFill>
-              </a:defRPr>
-            </a:pPr>
-            <a:r>
-              <a:t>Databricks Serverless</a:t>
-            </a:r>
-          </a:p>
-          <a:p>
-            <a:pPr>
-              <a:spcBef>
-                <a:spcPts val="600"/>
-              </a:spcBef>
-              <a:spcAft>
-                <a:spcPts val="300"/>
-              </a:spcAft>
-              <a:defRPr sz="1400" b="0">
-                <a:solidFill>
-                  <a:srgbClr val="404040"/>
-                </a:solidFill>
-              </a:defRPr>
-            </a:pPr>
-            <a:r>
-              <a:t>Apache Spark with PySpark</a:t>
-            </a:r>
-          </a:p>
-          <a:p>
-            <a:pPr>
-              <a:spcBef>
-                <a:spcPts val="600"/>
-              </a:spcBef>
-              <a:spcAft>
-                <a:spcPts val="300"/>
-              </a:spcAft>
-              <a:defRPr sz="1400" b="0">
-                <a:solidFill>
-                  <a:srgbClr val="404040"/>
-                </a:solidFill>
-              </a:defRPr>
-            </a:pPr>
-            <a:r>
-              <a:t>SQL for data transformation</a:t>
-            </a:r>
-          </a:p>
-        </p:txBody>
-      </p:sp>
-    </p:spTree>
-  </p:cSld>
-  <p:clrMapOvr>
-    <a:masterClrMapping/>
-  </p:clrMapOvr>
-</p:sld>
-</file>
-
-<file path=ppt/slides/slide3.xml><?xml version="1.0" encoding="utf-8"?>
-<p:sld xmlns:a="http://schemas.openxmlformats.org/drawingml/2006/main" xmlns:p="http://schemas.openxmlformats.org/presentationml/2006/main" xmlns:r="http://schemas.openxmlformats.org/officeDocument/2006/relationships">
-  <p:cSld>
-    <p:spTree>
-      <p:nvGrpSpPr>
-        <p:cNvPr id="1" name=""/>
-        <p:cNvGrpSpPr/>
-        <p:nvPr/>
-      </p:nvGrpSpPr>
-      <p:grpSpPr/>
-      <p:sp>
-        <p:nvSpPr>
-          <p:cNvPr id="2" name="TextBox 1"/>
-          <p:cNvSpPr txBox="1"/>
-          <p:nvPr/>
-        </p:nvSpPr>
-        <p:spPr>
-          <a:xfrm>
-            <a:off x="457200" y="274320"/>
-            <a:ext cx="8229600" cy="640080"/>
-          </a:xfrm>
-          <a:prstGeom prst="rect">
-            <a:avLst/>
-          </a:prstGeom>
-          <a:noFill/>
-        </p:spPr>
-        <p:txBody>
-          <a:bodyPr wrap="none">
-            <a:spAutoFit/>
-          </a:bodyPr>
-          <a:lstStyle/>
-          <a:p>
-            <a:pPr>
-              <a:defRPr sz="4000" b="1">
-                <a:solidFill>
-                  <a:srgbClr val="1F4E79"/>
-                </a:solidFill>
-              </a:defRPr>
-            </a:pPr>
-            <a:r>
-              <a:t>Why This is Big Data</a:t>
-            </a:r>
-          </a:p>
-        </p:txBody>
-      </p:sp>
-      <p:sp>
-        <p:nvSpPr>
-          <p:cNvPr id="3" name="TextBox 2"/>
-          <p:cNvSpPr txBox="1"/>
-          <p:nvPr/>
-        </p:nvSpPr>
-        <p:spPr>
-          <a:xfrm>
-            <a:off x="640080" y="1097280"/>
-            <a:ext cx="7863840" cy="5303520"/>
-          </a:xfrm>
-          <a:prstGeom prst="rect">
-            <a:avLst/>
-          </a:prstGeom>
-          <a:noFill/>
-        </p:spPr>
-        <p:txBody>
-          <a:bodyPr wrap="square">
-            <a:spAutoFit/>
-          </a:bodyPr>
-          <a:lstStyle/>
-          <a:p>
-            <a:pPr>
-              <a:spcBef>
-                <a:spcPts val="600"/>
-              </a:spcBef>
-              <a:spcAft>
-                <a:spcPts val="300"/>
-              </a:spcAft>
-              <a:defRPr sz="1600" b="1">
-                <a:solidFill>
-                  <a:srgbClr val="1F4E79"/>
-                </a:solidFill>
-              </a:defRPr>
-            </a:pPr>
-            <a:r>
-              <a:t>VOLUME</a:t>
-            </a:r>
-          </a:p>
-          <a:p>
-            <a:pPr>
-              <a:spcBef>
-                <a:spcPts val="600"/>
-              </a:spcBef>
-              <a:spcAft>
-                <a:spcPts val="300"/>
-              </a:spcAft>
-              <a:defRPr sz="1400" b="0">
-                <a:solidFill>
-                  <a:srgbClr val="404040"/>
-                </a:solidFill>
-              </a:defRPr>
-            </a:pPr>
-            <a:r>
-              <a:t>12 million records requires distributed processing</a:t>
-            </a:r>
-          </a:p>
-          <a:p>
-            <a:pPr>
-              <a:spcBef>
-                <a:spcPts val="600"/>
-              </a:spcBef>
-              <a:spcAft>
-                <a:spcPts val="300"/>
-              </a:spcAft>
-              <a:defRPr sz="1400" b="0">
-                <a:solidFill>
-                  <a:srgbClr val="404040"/>
-                </a:solidFill>
-              </a:defRPr>
-            </a:pPr>
-            <a:r>
-              <a:t>Cannot analyze on single machine in reasonable time</a:t>
-            </a:r>
-          </a:p>
-          <a:p>
-            <a:pPr>
-              <a:spcBef>
-                <a:spcPts val="600"/>
-              </a:spcBef>
-              <a:spcAft>
-                <a:spcPts val="300"/>
-              </a:spcAft>
-              <a:defRPr sz="1400" b="0">
-                <a:solidFill>
-                  <a:srgbClr val="404040"/>
-                </a:solidFill>
-              </a:defRPr>
-            </a:pPr>
-          </a:p>
-          <a:p>
-            <a:pPr>
-              <a:spcBef>
-                <a:spcPts val="600"/>
-              </a:spcBef>
-              <a:spcAft>
-                <a:spcPts val="300"/>
-              </a:spcAft>
-              <a:defRPr sz="1600" b="1">
-                <a:solidFill>
-                  <a:srgbClr val="1F4E79"/>
-                </a:solidFill>
-              </a:defRPr>
-            </a:pPr>
-            <a:r>
-              <a:t>VARIETY</a:t>
-            </a:r>
-          </a:p>
-          <a:p>
-            <a:pPr>
-              <a:spcBef>
-                <a:spcPts val="600"/>
-              </a:spcBef>
-              <a:spcAft>
-                <a:spcPts val="300"/>
-              </a:spcAft>
-              <a:defRPr sz="1400" b="0">
-                <a:solidFill>
-                  <a:srgbClr val="404040"/>
-                </a:solidFill>
-              </a:defRPr>
-            </a:pPr>
-            <a:r>
-              <a:t>Multiple data types: strings (titles), numbers (ratings), categories (genres)</a:t>
-            </a:r>
-          </a:p>
-          <a:p>
-            <a:pPr>
-              <a:spcBef>
-                <a:spcPts val="600"/>
-              </a:spcBef>
-              <a:spcAft>
-                <a:spcPts val="300"/>
-              </a:spcAft>
-              <a:defRPr sz="1400" b="0">
-                <a:solidFill>
-                  <a:srgbClr val="404040"/>
-                </a:solidFill>
-              </a:defRPr>
-            </a:pPr>
-            <a:r>
-              <a:t>Data from multiple sources: user ratings + metadata</a:t>
-            </a:r>
-          </a:p>
-          <a:p>
-            <a:pPr>
-              <a:spcBef>
-                <a:spcPts val="600"/>
-              </a:spcBef>
-              <a:spcAft>
-                <a:spcPts val="300"/>
-              </a:spcAft>
-              <a:defRPr sz="1400" b="0">
-                <a:solidFill>
-                  <a:srgbClr val="404040"/>
-                </a:solidFill>
-              </a:defRPr>
-            </a:pPr>
-          </a:p>
-          <a:p>
-            <a:pPr>
-              <a:spcBef>
-                <a:spcPts val="600"/>
-              </a:spcBef>
-              <a:spcAft>
-                <a:spcPts val="300"/>
-              </a:spcAft>
-              <a:defRPr sz="1600" b="1">
-                <a:solidFill>
-                  <a:srgbClr val="1F4E79"/>
-                </a:solidFill>
-              </a:defRPr>
-            </a:pPr>
-            <a:r>
-              <a:t>VERACITY</a:t>
-            </a:r>
-          </a:p>
-          <a:p>
-            <a:pPr>
-              <a:spcBef>
-                <a:spcPts val="600"/>
-              </a:spcBef>
-              <a:spcAft>
-                <a:spcPts val="300"/>
-              </a:spcAft>
-              <a:defRPr sz="1400" b="0">
-                <a:solidFill>
-                  <a:srgbClr val="404040"/>
-                </a:solidFill>
-              </a:defRPr>
-            </a:pPr>
-            <a:r>
-              <a:t>Missing data represented as \N (requires cleaning)</a:t>
-            </a:r>
-          </a:p>
-          <a:p>
-            <a:pPr>
-              <a:spcBef>
-                <a:spcPts val="600"/>
-              </a:spcBef>
-              <a:spcAft>
-                <a:spcPts val="300"/>
-              </a:spcAft>
-              <a:defRPr sz="1400" b="0">
-                <a:solidFill>
-                  <a:srgbClr val="404040"/>
-                </a:solidFill>
-              </a:defRPr>
-            </a:pPr>
-            <a:r>
-              <a:t>Null values in critical fields</a:t>
-            </a:r>
-          </a:p>
-        </p:txBody>
-      </p:sp>
-    </p:spTree>
-  </p:cSld>
-  <p:clrMapOvr>
-    <a:masterClrMapping/>
-  </p:clrMapOvr>
-</p:sld>
-</file>
-
-<file path=ppt/slides/slide4.xml><?xml version="1.0" encoding="utf-8"?>
-<p:sld xmlns:a="http://schemas.openxmlformats.org/drawingml/2006/main" xmlns:p="http://schemas.openxmlformats.org/presentationml/2006/main" xmlns:r="http://schemas.openxmlformats.org/officeDocument/2006/relationships">
-  <p:cSld>
-    <p:spTree>
-      <p:nvGrpSpPr>
-        <p:cNvPr id="1" name=""/>
-        <p:cNvGrpSpPr/>
-        <p:nvPr/>
-      </p:nvGrpSpPr>
-      <p:grpSpPr/>
-      <p:sp>
-        <p:nvSpPr>
-          <p:cNvPr id="2" name="TextBox 1"/>
-          <p:cNvSpPr txBox="1"/>
-          <p:nvPr/>
-        </p:nvSpPr>
-        <p:spPr>
-          <a:xfrm>
-            <a:off x="457200" y="274320"/>
-            <a:ext cx="8229600" cy="640080"/>
-          </a:xfrm>
-          <a:prstGeom prst="rect">
-            <a:avLst/>
-          </a:prstGeom>
-          <a:noFill/>
-        </p:spPr>
-        <p:txBody>
-          <a:bodyPr wrap="none">
-            <a:spAutoFit/>
-          </a:bodyPr>
-          <a:lstStyle/>
-          <a:p>
-            <a:pPr>
-              <a:defRPr sz="4000" b="1">
-                <a:solidFill>
-                  <a:srgbClr val="1F4E79"/>
-                </a:solidFill>
-              </a:defRPr>
-            </a:pPr>
-            <a:r>
-              <a:t>Chunk 01-02: Load Data from Databricks</a:t>
-            </a:r>
-          </a:p>
-        </p:txBody>
-      </p:sp>
-      <p:sp>
-        <p:nvSpPr>
-          <p:cNvPr id="3" name="TextBox 2"/>
-          <p:cNvSpPr txBox="1"/>
-          <p:nvPr/>
-        </p:nvSpPr>
-        <p:spPr>
-          <a:xfrm>
-            <a:off x="640080" y="1097280"/>
-            <a:ext cx="7863840" cy="5303520"/>
-          </a:xfrm>
-          <a:prstGeom prst="rect">
-            <a:avLst/>
-          </a:prstGeom>
-          <a:noFill/>
-        </p:spPr>
-        <p:txBody>
-          <a:bodyPr wrap="square">
-            <a:spAutoFit/>
-          </a:bodyPr>
-          <a:lstStyle/>
-          <a:p>
-            <a:pPr>
-              <a:spcBef>
-                <a:spcPts val="600"/>
-              </a:spcBef>
-              <a:spcAft>
-                <a:spcPts val="300"/>
-              </a:spcAft>
-              <a:defRPr sz="1600" b="1">
-                <a:solidFill>
-                  <a:srgbClr val="1F4E79"/>
-                </a:solidFill>
-              </a:defRPr>
-            </a:pPr>
-            <a:r>
-              <a:t>Code</a:t>
-            </a:r>
-          </a:p>
-          <a:p>
-            <a:pPr>
-              <a:spcBef>
-                <a:spcPts val="600"/>
-              </a:spcBef>
-              <a:spcAft>
-                <a:spcPts val="300"/>
-              </a:spcAft>
-              <a:defRPr sz="1400" b="0">
-                <a:solidFill>
-                  <a:srgbClr val="404040"/>
-                </a:solidFill>
-              </a:defRPr>
-            </a:pPr>
-            <a:r>
-              <a:t>spark.read.table('project.default.title_basics')</a:t>
-            </a:r>
-          </a:p>
-          <a:p>
-            <a:pPr>
-              <a:spcBef>
-                <a:spcPts val="600"/>
-              </a:spcBef>
-              <a:spcAft>
-                <a:spcPts val="300"/>
-              </a:spcAft>
-              <a:defRPr sz="1400" b="0">
-                <a:solidFill>
-                  <a:srgbClr val="404040"/>
-                </a:solidFill>
-              </a:defRPr>
-            </a:pPr>
-            <a:r>
-              <a:t>spark.read.table('project.default.title_ratings')</a:t>
-            </a:r>
-          </a:p>
-          <a:p>
-            <a:pPr>
-              <a:spcBef>
-                <a:spcPts val="600"/>
-              </a:spcBef>
-              <a:spcAft>
-                <a:spcPts val="300"/>
-              </a:spcAft>
-              <a:defRPr sz="1400" b="0">
-                <a:solidFill>
-                  <a:srgbClr val="404040"/>
-                </a:solidFill>
-              </a:defRPr>
-            </a:pPr>
-          </a:p>
-          <a:p>
-            <a:pPr>
-              <a:spcBef>
-                <a:spcPts val="600"/>
-              </a:spcBef>
-              <a:spcAft>
-                <a:spcPts val="300"/>
-              </a:spcAft>
-              <a:defRPr sz="1600" b="1">
-                <a:solidFill>
-                  <a:srgbClr val="1F4E79"/>
-                </a:solidFill>
-              </a:defRPr>
-            </a:pPr>
-            <a:r>
-              <a:t>Result</a:t>
-            </a:r>
-          </a:p>
-          <a:p>
-            <a:pPr>
-              <a:spcBef>
-                <a:spcPts val="600"/>
-              </a:spcBef>
-              <a:spcAft>
-                <a:spcPts val="300"/>
-              </a:spcAft>
-              <a:defRPr sz="1400" b="0">
-                <a:solidFill>
-                  <a:srgbClr val="404040"/>
-                </a:solidFill>
-              </a:defRPr>
-            </a:pPr>
-            <a:r>
-              <a:t>title_basics: 330,970 movies with metadata</a:t>
-            </a:r>
-          </a:p>
-          <a:p>
-            <a:pPr>
-              <a:spcBef>
-                <a:spcPts val="600"/>
-              </a:spcBef>
-              <a:spcAft>
-                <a:spcPts val="300"/>
-              </a:spcAft>
-              <a:defRPr sz="1400" b="0">
-                <a:solidFill>
-                  <a:srgbClr val="404040"/>
-                </a:solidFill>
-              </a:defRPr>
-            </a:pPr>
-            <a:r>
-              <a:t>title_ratings: 1,600,000+ user ratings</a:t>
-            </a:r>
-          </a:p>
-          <a:p>
-            <a:pPr>
-              <a:spcBef>
-                <a:spcPts val="600"/>
-              </a:spcBef>
-              <a:spcAft>
-                <a:spcPts val="300"/>
-              </a:spcAft>
-              <a:defRPr sz="1400" b="0">
-                <a:solidFill>
-                  <a:srgbClr val="404040"/>
-                </a:solidFill>
-              </a:defRPr>
-            </a:pPr>
-            <a:r>
-              <a:t>display() shows first 20 rows of each table</a:t>
-            </a:r>
-          </a:p>
-        </p:txBody>
-      </p:sp>
-    </p:spTree>
-  </p:cSld>
-  <p:clrMapOvr>
-    <a:masterClrMapping/>
-  </p:clrMapOvr>
-</p:sld>
-</file>
-
-<file path=ppt/slides/slide5.xml><?xml version="1.0" encoding="utf-8"?>
-<p:sld xmlns:a="http://schemas.openxmlformats.org/drawingml/2006/main" xmlns:p="http://schemas.openxmlformats.org/presentationml/2006/main" xmlns:r="http://schemas.openxmlformats.org/officeDocument/2006/relationships">
-  <p:cSld>
-    <p:spTree>
-      <p:nvGrpSpPr>
-        <p:cNvPr id="1" name=""/>
-        <p:cNvGrpSpPr/>
-        <p:nvPr/>
-      </p:nvGrpSpPr>
-      <p:grpSpPr/>
-      <p:sp>
-        <p:nvSpPr>
-          <p:cNvPr id="2" name="TextBox 1"/>
-          <p:cNvSpPr txBox="1"/>
-          <p:nvPr/>
-        </p:nvSpPr>
-        <p:spPr>
-          <a:xfrm>
-            <a:off x="457200" y="274320"/>
-            <a:ext cx="8229600" cy="640080"/>
-          </a:xfrm>
-          <a:prstGeom prst="rect">
-            <a:avLst/>
-          </a:prstGeom>
-          <a:noFill/>
-        </p:spPr>
-        <p:txBody>
-          <a:bodyPr wrap="none">
-            <a:spAutoFit/>
-          </a:bodyPr>
-          <a:lstStyle/>
-          <a:p>
-            <a:pPr>
-              <a:defRPr sz="4000" b="1">
-                <a:solidFill>
-                  <a:srgbClr val="1F4E79"/>
-                </a:solidFill>
-              </a:defRPr>
-            </a:pPr>
-            <a:r>
-              <a:t>Chunk 03: Clean Missing Values</a:t>
-            </a:r>
-          </a:p>
-        </p:txBody>
-      </p:sp>
-      <p:sp>
-        <p:nvSpPr>
-          <p:cNvPr id="3" name="TextBox 2"/>
-          <p:cNvSpPr txBox="1"/>
-          <p:nvPr/>
-        </p:nvSpPr>
-        <p:spPr>
-          <a:xfrm>
-            <a:off x="640080" y="1097280"/>
-            <a:ext cx="7863840" cy="5303520"/>
-          </a:xfrm>
-          <a:prstGeom prst="rect">
-            <a:avLst/>
-          </a:prstGeom>
-          <a:noFill/>
-        </p:spPr>
-        <p:txBody>
-          <a:bodyPr wrap="square">
-            <a:spAutoFit/>
-          </a:bodyPr>
-          <a:lstStyle/>
-          <a:p>
-            <a:pPr>
-              <a:spcBef>
-                <a:spcPts val="600"/>
-              </a:spcBef>
-              <a:spcAft>
-                <a:spcPts val="300"/>
-              </a:spcAft>
-              <a:defRPr sz="1600" b="1">
-                <a:solidFill>
-                  <a:srgbClr val="1F4E79"/>
-                </a:solidFill>
-              </a:defRPr>
-            </a:pPr>
-            <a:r>
-              <a:t>Problem</a:t>
-            </a:r>
-          </a:p>
-          <a:p>
-            <a:pPr>
-              <a:spcBef>
-                <a:spcPts val="600"/>
-              </a:spcBef>
-              <a:spcAft>
-                <a:spcPts val="300"/>
-              </a:spcAft>
-              <a:defRPr sz="1400" b="0">
-                <a:solidFill>
-                  <a:srgbClr val="404040"/>
-                </a:solidFill>
-              </a:defRPr>
-            </a:pPr>
-            <a:r>
-              <a:t>IMDb represents missing data as string \N</a:t>
-            </a:r>
-          </a:p>
-          <a:p>
-            <a:pPr>
-              <a:spcBef>
-                <a:spcPts val="600"/>
-              </a:spcBef>
-              <a:spcAft>
-                <a:spcPts val="300"/>
-              </a:spcAft>
-              <a:defRPr sz="1400" b="0">
-                <a:solidFill>
-                  <a:srgbClr val="404040"/>
-                </a:solidFill>
-              </a:defRPr>
-            </a:pPr>
-            <a:r>
-              <a:t>This breaks calculations and aggregations</a:t>
-            </a:r>
-          </a:p>
-          <a:p>
-            <a:pPr>
-              <a:spcBef>
-                <a:spcPts val="600"/>
-              </a:spcBef>
-              <a:spcAft>
-                <a:spcPts val="300"/>
-              </a:spcAft>
-              <a:defRPr sz="1400" b="0">
-                <a:solidFill>
-                  <a:srgbClr val="404040"/>
-                </a:solidFill>
-              </a:defRPr>
-            </a:pPr>
-          </a:p>
-          <a:p>
-            <a:pPr>
-              <a:spcBef>
-                <a:spcPts val="600"/>
-              </a:spcBef>
-              <a:spcAft>
-                <a:spcPts val="300"/>
-              </a:spcAft>
-              <a:defRPr sz="1600" b="1">
-                <a:solidFill>
-                  <a:srgbClr val="1F4E79"/>
-                </a:solidFill>
-              </a:defRPr>
-            </a:pPr>
-            <a:r>
-              <a:t>Solution</a:t>
-            </a:r>
-          </a:p>
-          <a:p>
-            <a:pPr>
-              <a:spcBef>
-                <a:spcPts val="600"/>
-              </a:spcBef>
-              <a:spcAft>
-                <a:spcPts val="300"/>
-              </a:spcAft>
-              <a:defRPr sz="1400" b="0">
-                <a:solidFill>
-                  <a:srgbClr val="404040"/>
-                </a:solidFill>
-              </a:defRPr>
-            </a:pPr>
-            <a:r>
-              <a:t>Replace all \N with proper NULL values</a:t>
-            </a:r>
-          </a:p>
-          <a:p>
-            <a:pPr>
-              <a:spcBef>
-                <a:spcPts val="600"/>
-              </a:spcBef>
-              <a:spcAft>
-                <a:spcPts val="300"/>
-              </a:spcAft>
-              <a:defRPr sz="1400" b="0">
-                <a:solidFill>
-                  <a:srgbClr val="404040"/>
-                </a:solidFill>
-              </a:defRPr>
-            </a:pPr>
-            <a:r>
-              <a:t>Allows Spark to handle missing data correctly</a:t>
-            </a:r>
-          </a:p>
-          <a:p>
-            <a:pPr>
-              <a:spcBef>
-                <a:spcPts val="600"/>
-              </a:spcBef>
-              <a:spcAft>
-                <a:spcPts val="300"/>
-              </a:spcAft>
-              <a:defRPr sz="1400" b="0">
-                <a:solidFill>
-                  <a:srgbClr val="404040"/>
-                </a:solidFill>
-              </a:defRPr>
-            </a:pPr>
-          </a:p>
-          <a:p>
-            <a:pPr>
-              <a:spcBef>
-                <a:spcPts val="600"/>
-              </a:spcBef>
-              <a:spcAft>
-                <a:spcPts val="300"/>
-              </a:spcAft>
-              <a:defRPr sz="1600" b="1">
-                <a:solidFill>
-                  <a:srgbClr val="1F4E79"/>
-                </a:solidFill>
-              </a:defRPr>
-            </a:pPr>
-            <a:r>
-              <a:t>Code</a:t>
-            </a:r>
-          </a:p>
-          <a:p>
-            <a:pPr>
-              <a:spcBef>
-                <a:spcPts val="600"/>
-              </a:spcBef>
-              <a:spcAft>
-                <a:spcPts val="300"/>
-              </a:spcAft>
-              <a:defRPr sz="1400" b="0">
-                <a:solidFill>
-                  <a:srgbClr val="404040"/>
-                </a:solidFill>
-              </a:defRPr>
-            </a:pPr>
-            <a:r>
-              <a:t>.replace('\\N', None)</a:t>
-            </a:r>
-          </a:p>
-        </p:txBody>
-      </p:sp>
-    </p:spTree>
-  </p:cSld>
-  <p:clrMapOvr>
-    <a:masterClrMapping/>
-  </p:clrMapOvr>
-</p:sld>
-</file>
-
-<file path=ppt/slides/slide6.xml><?xml version="1.0" encoding="utf-8"?>
-<p:sld xmlns:a="http://schemas.openxmlformats.org/drawingml/2006/main" xmlns:p="http://schemas.openxmlformats.org/presentationml/2006/main" xmlns:r="http://schemas.openxmlformats.org/officeDocument/2006/relationships">
-  <p:cSld>
-    <p:spTree>
-      <p:nvGrpSpPr>
-        <p:cNvPr id="1" name=""/>
-        <p:cNvGrpSpPr/>
-        <p:nvPr/>
-      </p:nvGrpSpPr>
-      <p:grpSpPr/>
-      <p:sp>
-        <p:nvSpPr>
-          <p:cNvPr id="2" name="TextBox 1"/>
-          <p:cNvSpPr txBox="1"/>
-          <p:nvPr/>
-        </p:nvSpPr>
-        <p:spPr>
-          <a:xfrm>
-            <a:off x="457200" y="274320"/>
-            <a:ext cx="8229600" cy="640080"/>
-          </a:xfrm>
-          <a:prstGeom prst="rect">
-            <a:avLst/>
-          </a:prstGeom>
-          <a:noFill/>
-        </p:spPr>
-        <p:txBody>
-          <a:bodyPr wrap="none">
-            <a:spAutoFit/>
-          </a:bodyPr>
-          <a:lstStyle/>
-          <a:p>
-            <a:pPr>
-              <a:defRPr sz="4000" b="1">
-                <a:solidFill>
-                  <a:srgbClr val="1F4E79"/>
-                </a:solidFill>
-              </a:defRPr>
-            </a:pPr>
-            <a:r>
-              <a:t>Chunk 04-05: Join Tables &amp; Filter Movies</a:t>
-            </a:r>
-          </a:p>
-        </p:txBody>
-      </p:sp>
-      <p:sp>
-        <p:nvSpPr>
-          <p:cNvPr id="3" name="TextBox 2"/>
-          <p:cNvSpPr txBox="1"/>
-          <p:nvPr/>
-        </p:nvSpPr>
-        <p:spPr>
-          <a:xfrm>
-            <a:off x="640080" y="1097280"/>
-            <a:ext cx="7863840" cy="5303520"/>
-          </a:xfrm>
-          <a:prstGeom prst="rect">
-            <a:avLst/>
-          </a:prstGeom>
-          <a:noFill/>
-        </p:spPr>
-        <p:txBody>
-          <a:bodyPr wrap="square">
-            <a:spAutoFit/>
-          </a:bodyPr>
-          <a:lstStyle/>
-          <a:p>
-            <a:pPr>
-              <a:spcBef>
-                <a:spcPts val="600"/>
-              </a:spcBef>
-              <a:spcAft>
-                <a:spcPts val="300"/>
-              </a:spcAft>
-              <a:defRPr sz="1600" b="1">
-                <a:solidFill>
-                  <a:srgbClr val="1F4E79"/>
-                </a:solidFill>
-              </a:defRPr>
-            </a:pPr>
-            <a:r>
-              <a:t>Chunk 04: Inner Join</a:t>
-            </a:r>
-          </a:p>
-          <a:p>
-            <a:pPr>
-              <a:spcBef>
-                <a:spcPts val="600"/>
-              </a:spcBef>
-              <a:spcAft>
-                <a:spcPts val="300"/>
-              </a:spcAft>
-              <a:defRPr sz="1400" b="0">
-                <a:solidFill>
-                  <a:srgbClr val="404040"/>
-                </a:solidFill>
-              </a:defRPr>
-            </a:pPr>
-            <a:r>
-              <a:t>Combine title_basics + title_ratings on tconst (unique ID)</a:t>
-            </a:r>
-          </a:p>
-          <a:p>
-            <a:pPr>
-              <a:spcBef>
-                <a:spcPts val="600"/>
-              </a:spcBef>
-              <a:spcAft>
-                <a:spcPts val="300"/>
-              </a:spcAft>
-              <a:defRPr sz="1400" b="0">
-                <a:solidFill>
-                  <a:srgbClr val="404040"/>
-                </a:solidFill>
-              </a:defRPr>
-            </a:pPr>
-            <a:r>
-              <a:t>Result: Movies with both metadata AND ratings</a:t>
-            </a:r>
-          </a:p>
-          <a:p>
-            <a:pPr>
-              <a:spcBef>
-                <a:spcPts val="600"/>
-              </a:spcBef>
-              <a:spcAft>
-                <a:spcPts val="300"/>
-              </a:spcAft>
-              <a:defRPr sz="1400" b="0">
-                <a:solidFill>
-                  <a:srgbClr val="404040"/>
-                </a:solidFill>
-              </a:defRPr>
-            </a:pPr>
-          </a:p>
-          <a:p>
-            <a:pPr>
-              <a:spcBef>
-                <a:spcPts val="600"/>
-              </a:spcBef>
-              <a:spcAft>
-                <a:spcPts val="300"/>
-              </a:spcAft>
-              <a:defRPr sz="1600" b="1">
-                <a:solidFill>
-                  <a:srgbClr val="1F4E79"/>
-                </a:solidFill>
-              </a:defRPr>
-            </a:pPr>
-            <a:r>
-              <a:t>Chunk 05: Filter to Movies Only</a:t>
-            </a:r>
-          </a:p>
-          <a:p>
-            <a:pPr>
-              <a:spcBef>
-                <a:spcPts val="600"/>
-              </a:spcBef>
-              <a:spcAft>
-                <a:spcPts val="300"/>
-              </a:spcAft>
-              <a:defRPr sz="1400" b="0">
-                <a:solidFill>
-                  <a:srgbClr val="404040"/>
-                </a:solidFill>
-              </a:defRPr>
-            </a:pPr>
-            <a:r>
-              <a:t>Remove TV shows, shorts, other content</a:t>
-            </a:r>
-          </a:p>
-          <a:p>
-            <a:pPr>
-              <a:spcBef>
-                <a:spcPts val="600"/>
-              </a:spcBef>
-              <a:spcAft>
-                <a:spcPts val="300"/>
-              </a:spcAft>
-              <a:defRPr sz="1400" b="0">
-                <a:solidFill>
-                  <a:srgbClr val="404040"/>
-                </a:solidFill>
-              </a:defRPr>
-            </a:pPr>
-            <a:r>
-              <a:t>Keep only records where titleType == 'movie'</a:t>
-            </a:r>
-          </a:p>
-          <a:p>
-            <a:pPr>
-              <a:spcBef>
-                <a:spcPts val="600"/>
-              </a:spcBef>
-              <a:spcAft>
-                <a:spcPts val="300"/>
-              </a:spcAft>
-              <a:defRPr sz="1400" b="0">
-                <a:solidFill>
-                  <a:srgbClr val="404040"/>
-                </a:solidFill>
-              </a:defRPr>
-            </a:pPr>
-            <a:r>
-              <a:t>Remove nulls in critical columns</a:t>
-            </a:r>
-          </a:p>
-        </p:txBody>
-      </p:sp>
-    </p:spTree>
-  </p:cSld>
-  <p:clrMapOvr>
-    <a:masterClrMapping/>
-  </p:clrMapOvr>
-</p:sld>
-</file>
-
-<file path=ppt/slides/slide7.xml><?xml version="1.0" encoding="utf-8"?>
-<p:sld xmlns:a="http://schemas.openxmlformats.org/drawingml/2006/main" xmlns:p="http://schemas.openxmlformats.org/presentationml/2006/main" xmlns:r="http://schemas.openxmlformats.org/officeDocument/2006/relationships">
-  <p:cSld>
-    <p:spTree>
-      <p:nvGrpSpPr>
-        <p:cNvPr id="1" name=""/>
-        <p:cNvGrpSpPr/>
-        <p:nvPr/>
-      </p:nvGrpSpPr>
-      <p:grpSpPr/>
-      <p:sp>
-        <p:nvSpPr>
-          <p:cNvPr id="2" name="TextBox 1"/>
-          <p:cNvSpPr txBox="1"/>
-          <p:nvPr/>
-        </p:nvSpPr>
-        <p:spPr>
-          <a:xfrm>
-            <a:off x="457200" y="274320"/>
-            <a:ext cx="8229600" cy="640080"/>
-          </a:xfrm>
-          <a:prstGeom prst="rect">
-            <a:avLst/>
-          </a:prstGeom>
-          <a:noFill/>
-        </p:spPr>
-        <p:txBody>
-          <a:bodyPr wrap="none">
-            <a:spAutoFit/>
-          </a:bodyPr>
-          <a:lstStyle/>
-          <a:p>
-            <a:pPr>
-              <a:defRPr sz="4000" b="1">
-                <a:solidFill>
-                  <a:srgbClr val="1F4E79"/>
-                </a:solidFill>
-              </a:defRPr>
-            </a:pPr>
-            <a:r>
-              <a:t>Chunk 06: Convert Data Types</a:t>
-            </a:r>
-          </a:p>
-        </p:txBody>
-      </p:sp>
-      <p:sp>
-        <p:nvSpPr>
-          <p:cNvPr id="3" name="TextBox 2"/>
-          <p:cNvSpPr txBox="1"/>
-          <p:nvPr/>
-        </p:nvSpPr>
-        <p:spPr>
-          <a:xfrm>
-            <a:off x="640080" y="1097280"/>
-            <a:ext cx="7863840" cy="5303520"/>
-          </a:xfrm>
-          <a:prstGeom prst="rect">
-            <a:avLst/>
-          </a:prstGeom>
-          <a:noFill/>
-        </p:spPr>
-        <p:txBody>
-          <a:bodyPr wrap="square">
-            <a:spAutoFit/>
-          </a:bodyPr>
-          <a:lstStyle/>
-          <a:p>
-            <a:pPr>
-              <a:spcBef>
-                <a:spcPts val="600"/>
-              </a:spcBef>
-              <a:spcAft>
-                <a:spcPts val="300"/>
-              </a:spcAft>
-              <a:defRPr sz="1600" b="1">
-                <a:solidFill>
-                  <a:srgbClr val="1F4E79"/>
-                </a:solidFill>
-              </a:defRPr>
-            </a:pPr>
-            <a:r>
-              <a:t>Why Needed</a:t>
-            </a:r>
-          </a:p>
-          <a:p>
-            <a:pPr>
-              <a:spcBef>
-                <a:spcPts val="600"/>
-              </a:spcBef>
-              <a:spcAft>
-                <a:spcPts val="300"/>
-              </a:spcAft>
-              <a:defRPr sz="1400" b="0">
-                <a:solidFill>
-                  <a:srgbClr val="404040"/>
-                </a:solidFill>
-              </a:defRPr>
-            </a:pPr>
-            <a:r>
-              <a:t>Data arrives as strings, need numbers for math</a:t>
-            </a:r>
-          </a:p>
-          <a:p>
-            <a:pPr>
-              <a:spcBef>
-                <a:spcPts val="600"/>
-              </a:spcBef>
-              <a:spcAft>
-                <a:spcPts val="300"/>
-              </a:spcAft>
-              <a:defRPr sz="1400" b="0">
-                <a:solidFill>
-                  <a:srgbClr val="404040"/>
-                </a:solidFill>
-              </a:defRPr>
-            </a:pPr>
-          </a:p>
-          <a:p>
-            <a:pPr>
-              <a:spcBef>
-                <a:spcPts val="600"/>
-              </a:spcBef>
-              <a:spcAft>
-                <a:spcPts val="300"/>
-              </a:spcAft>
-              <a:defRPr sz="1600" b="1">
-                <a:solidFill>
-                  <a:srgbClr val="1F4E79"/>
-                </a:solidFill>
-              </a:defRPr>
-            </a:pPr>
-            <a:r>
-              <a:t>Conversions Applied</a:t>
-            </a:r>
-          </a:p>
-          <a:p>
-            <a:pPr>
-              <a:spcBef>
-                <a:spcPts val="600"/>
-              </a:spcBef>
-              <a:spcAft>
-                <a:spcPts val="300"/>
-              </a:spcAft>
-              <a:defRPr sz="1400" b="0">
-                <a:solidFill>
-                  <a:srgbClr val="404040"/>
-                </a:solidFill>
-              </a:defRPr>
-            </a:pPr>
-            <a:r>
-              <a:t>startYear -&gt; integer (years like 2024)</a:t>
-            </a:r>
-          </a:p>
-          <a:p>
-            <a:pPr>
-              <a:spcBef>
-                <a:spcPts val="600"/>
-              </a:spcBef>
-              <a:spcAft>
-                <a:spcPts val="300"/>
-              </a:spcAft>
-              <a:defRPr sz="1400" b="0">
-                <a:solidFill>
-                  <a:srgbClr val="404040"/>
-                </a:solidFill>
-              </a:defRPr>
-            </a:pPr>
-            <a:r>
-              <a:t>runtimeMinutes -&gt; integer (minutes like 120)</a:t>
-            </a:r>
-          </a:p>
-          <a:p>
-            <a:pPr>
-              <a:spcBef>
-                <a:spcPts val="600"/>
-              </a:spcBef>
-              <a:spcAft>
-                <a:spcPts val="300"/>
-              </a:spcAft>
-              <a:defRPr sz="1400" b="0">
-                <a:solidFill>
-                  <a:srgbClr val="404040"/>
-                </a:solidFill>
-              </a:defRPr>
-            </a:pPr>
-            <a:r>
-              <a:t>averageRating -&gt; double (ratings like 7.5)</a:t>
-            </a:r>
-          </a:p>
-          <a:p>
-            <a:pPr>
-              <a:spcBef>
-                <a:spcPts val="600"/>
-              </a:spcBef>
-              <a:spcAft>
-                <a:spcPts val="300"/>
-              </a:spcAft>
-              <a:defRPr sz="1400" b="0">
-                <a:solidFill>
-                  <a:srgbClr val="404040"/>
-                </a:solidFill>
-              </a:defRPr>
-            </a:pPr>
-            <a:r>
-              <a:t>numVotes -&gt; integer (vote counts like 50000)</a:t>
-            </a:r>
-          </a:p>
-        </p:txBody>
-      </p:sp>
-    </p:spTree>
-  </p:cSld>
-  <p:clrMapOvr>
-    <a:masterClrMapping/>
-  </p:clrMapOvr>
-</p:sld>
-</file>
-
-<file path=ppt/slides/slide8.xml><?xml version="1.0" encoding="utf-8"?>
-<p:sld xmlns:a="http://schemas.openxmlformats.org/drawingml/2006/main" xmlns:p="http://schemas.openxmlformats.org/presentationml/2006/main" xmlns:r="http://schemas.openxmlformats.org/officeDocument/2006/relationships">
-  <p:cSld>
-    <p:spTree>
-      <p:nvGrpSpPr>
-        <p:cNvPr id="1" name=""/>
-        <p:cNvGrpSpPr/>
-        <p:nvPr/>
-      </p:nvGrpSpPr>
-      <p:grpSpPr/>
-      <p:sp>
-        <p:nvSpPr>
-          <p:cNvPr id="2" name="TextBox 1"/>
-          <p:cNvSpPr txBox="1"/>
-          <p:nvPr/>
-        </p:nvSpPr>
-        <p:spPr>
-          <a:xfrm>
-            <a:off x="457200" y="274320"/>
-            <a:ext cx="8229600" cy="548640"/>
-          </a:xfrm>
-          <a:prstGeom prst="rect">
-            <a:avLst/>
-          </a:prstGeom>
-          <a:noFill/>
-        </p:spPr>
-        <p:txBody>
-          <a:bodyPr wrap="none">
-            <a:spAutoFit/>
-          </a:bodyPr>
-          <a:lstStyle/>
-          <a:p>
-            <a:pPr>
-              <a:defRPr sz="3200" b="1">
-                <a:solidFill>
-                  <a:srgbClr val="1F4E79"/>
-                </a:solidFill>
-              </a:defRPr>
-            </a:pPr>
-            <a:r>
-              <a:t>Chunk 07: Top 20 Highest-Rated Movies</a:t>
-            </a:r>
-          </a:p>
-        </p:txBody>
-      </p:sp>
-      <p:pic>
-        <p:nvPicPr>
-          <p:cNvPr id="3" name="Picture 2" descr="v0_viz_1_top_rated.png"/>
-          <p:cNvPicPr>
-            <a:picLocks noChangeAspect="1"/>
-          </p:cNvPicPr>
-          <p:nvPr/>
-        </p:nvPicPr>
-        <p:blipFill>
-          <a:blip r:embed="rId2"/>
-          <a:stretch>
-            <a:fillRect/>
-          </a:stretch>
-        </p:blipFill>
-        <p:spPr>
-          <a:xfrm>
-            <a:off x="457200" y="914400"/>
-            <a:ext cx="8229600" cy="5452571"/>
-          </a:xfrm>
-          <a:prstGeom prst="rect">
-            <a:avLst/>
-          </a:prstGeom>
-        </p:spPr>
-      </p:pic>
-    </p:spTree>
-  </p:cSld>
-  <p:clrMapOvr>
-    <a:masterClrMapping/>
-  </p:clrMapOvr>
-</p:sld>
-</file>
-
-<file path=ppt/slides/slide9.xml><?xml version="1.0" encoding="utf-8"?>
-<p:sld xmlns:a="http://schemas.openxmlformats.org/drawingml/2006/main" xmlns:p="http://schemas.openxmlformats.org/presentationml/2006/main" xmlns:r="http://schemas.openxmlformats.org/officeDocument/2006/relationships">
-  <p:cSld>
-    <p:spTree>
-      <p:nvGrpSpPr>
-        <p:cNvPr id="1" name=""/>
-        <p:cNvGrpSpPr/>
-        <p:nvPr/>
-      </p:nvGrpSpPr>
-      <p:grpSpPr/>
-      <p:sp>
-        <p:nvSpPr>
-          <p:cNvPr id="2" name="TextBox 1"/>
-          <p:cNvSpPr txBox="1"/>
-          <p:nvPr/>
-        </p:nvSpPr>
-        <p:spPr>
-          <a:xfrm>
-            <a:off x="457200" y="274320"/>
-            <a:ext cx="8229600" cy="548640"/>
-          </a:xfrm>
-          <a:prstGeom prst="rect">
-            <a:avLst/>
-          </a:prstGeom>
-          <a:noFill/>
-        </p:spPr>
-        <p:txBody>
-          <a:bodyPr wrap="none">
-            <a:spAutoFit/>
-          </a:bodyPr>
-          <a:lstStyle/>
-          <a:p>
-            <a:pPr>
-              <a:defRPr sz="3200" b="1">
-                <a:solidFill>
-                  <a:srgbClr val="1F4E79"/>
-                </a:solidFill>
-              </a:defRPr>
-            </a:pPr>
-            <a:r>
-              <a:t>Chunk 08 &amp; 10: Movie Production Over Time</a:t>
-            </a:r>
-          </a:p>
-        </p:txBody>
-      </p:sp>
-      <p:pic>
-        <p:nvPicPr>
-          <p:cNvPr id="3" name="Picture 2" descr="v0_viz_2_movies_by_year.png"/>
-          <p:cNvPicPr>
-            <a:picLocks noChangeAspect="1"/>
-          </p:cNvPicPr>
-          <p:nvPr/>
-        </p:nvPicPr>
-        <p:blipFill>
-          <a:blip r:embed="rId2"/>
-          <a:stretch>
-            <a:fillRect/>
-          </a:stretch>
-        </p:blipFill>
-        <p:spPr>
-          <a:xfrm>
-            <a:off x="457200" y="914400"/>
-            <a:ext cx="8229600" cy="3751167"/>
+            <a:ext cx="8229600" cy="5184396"/>
           </a:xfrm>
           <a:prstGeom prst="rect">
             <a:avLst/>

</xml_diff>